<commit_message>
Fix scrap/TMT PDF extraction and regenerate graphs for Jul–Sep 2026 updates
find_scrap stopped at summary pages mentioning 'Melting Scrap'; now requires
the 'Melting Scrap (India)' table. find_tmt_v2 skipped the Ex-Raipur rebar
row on continuation pages without a 'Rebar (India)' header.

Co-Authored-By: Claude Opus 5.5 <noreply@anthropic.com>
Claude-Session: https://claude.ai/code/session_01MztwMJnz2CCbYvjHcZqkdz
</commit_message>
<xml_diff>
--- a/output/material_change_graphs.pptx
+++ b/output/material_change_graphs.pptx
@@ -170,9 +170,9 @@
           </c:dLbls>
           <c:cat>
             <c:multiLvlStrRef>
-              <c:f>Sheet1!$A$2:$A$21</c:f>
+              <c:f>Sheet1!$A$2:$A$23</c:f>
               <c:multiLvlStrCache>
-                <c:ptCount val="20"/>
+                <c:ptCount val="22"/>
                 <c:lvl>
                   <c:pt idx="0">
                     <c:v>Dec'24</c:v>
@@ -251,7 +251,15 @@
                   </c:pt>
                   <c:pt idx="19">
                     <c:v>Jul'26
-R:-300 | N:-1,600</c:v>
+R:-100 | N:-500</c:v>
+                  </c:pt>
+                  <c:pt idx="20">
+                    <c:v>Aug'26
+R:+2,300 | N:+4,500</c:v>
+                  </c:pt>
+                  <c:pt idx="21">
+                    <c:v>Sep'26
+R:+500 | N:+500</c:v>
                   </c:pt>
                 </c:lvl>
               </c:multiLvlStrCache>
@@ -259,10 +267,10 @@
           </c:cat>
           <c:val>
             <c:numRef>
-              <c:f>Sheet1!$B$2:$B$21</c:f>
+              <c:f>Sheet1!$B$2:$B$23</c:f>
               <c:numCache>
                 <c:formatCode>General</c:formatCode>
-                <c:ptCount val="20"/>
+                <c:ptCount val="22"/>
                 <c:pt idx="0">
                   <c:v>31300</c:v>
                 </c:pt>
@@ -321,7 +329,13 @@
                   <c:v>34300</c:v>
                 </c:pt>
                 <c:pt idx="19">
-                  <c:v>34000</c:v>
+                  <c:v>34200</c:v>
+                </c:pt>
+                <c:pt idx="20">
+                  <c:v>36500</c:v>
+                </c:pt>
+                <c:pt idx="21">
+                  <c:v>37000</c:v>
                 </c:pt>
               </c:numCache>
             </c:numRef>
@@ -374,9 +388,9 @@
           </c:dLbls>
           <c:cat>
             <c:multiLvlStrRef>
-              <c:f>Sheet1!$A$2:$A$21</c:f>
+              <c:f>Sheet1!$A$2:$A$23</c:f>
               <c:multiLvlStrCache>
-                <c:ptCount val="20"/>
+                <c:ptCount val="22"/>
                 <c:lvl>
                   <c:pt idx="0">
                     <c:v>Dec'24</c:v>
@@ -455,7 +469,15 @@
                   </c:pt>
                   <c:pt idx="19">
                     <c:v>Jul'26
-R:-300 | N:-1,600</c:v>
+R:-100 | N:-500</c:v>
+                  </c:pt>
+                  <c:pt idx="20">
+                    <c:v>Aug'26
+R:+2,300 | N:+4,500</c:v>
+                  </c:pt>
+                  <c:pt idx="21">
+                    <c:v>Sep'26
+R:+500 | N:+500</c:v>
                   </c:pt>
                 </c:lvl>
               </c:multiLvlStrCache>
@@ -463,10 +485,10 @@
           </c:cat>
           <c:val>
             <c:numRef>
-              <c:f>Sheet1!$C$2:$C$21</c:f>
+              <c:f>Sheet1!$C$2:$C$23</c:f>
               <c:numCache>
                 <c:formatCode>General</c:formatCode>
-                <c:ptCount val="20"/>
+                <c:ptCount val="22"/>
                 <c:pt idx="0">
                   <c:v>33100</c:v>
                 </c:pt>
@@ -525,7 +547,13 @@
                   <c:v>34900</c:v>
                 </c:pt>
                 <c:pt idx="19">
-                  <c:v>33300</c:v>
+                  <c:v>34400</c:v>
+                </c:pt>
+                <c:pt idx="20">
+                  <c:v>38900</c:v>
+                </c:pt>
+                <c:pt idx="21">
+                  <c:v>39400</c:v>
                 </c:pt>
               </c:numCache>
             </c:numRef>
@@ -779,9 +807,9 @@
           </c:marker>
           <c:cat>
             <c:multiLvlStrRef>
-              <c:f>Sheet1!$A$2:$A$21</c:f>
+              <c:f>Sheet1!$A$2:$A$23</c:f>
               <c:multiLvlStrCache>
-                <c:ptCount val="20"/>
+                <c:ptCount val="22"/>
                 <c:lvl>
                   <c:pt idx="0">
                     <c:v>Dec'24</c:v>
@@ -842,6 +870,12 @@
                   </c:pt>
                   <c:pt idx="19">
                     <c:v>Jul'26</c:v>
+                  </c:pt>
+                  <c:pt idx="20">
+                    <c:v>Aug'26</c:v>
+                  </c:pt>
+                  <c:pt idx="21">
+                    <c:v>Sep'26</c:v>
                   </c:pt>
                 </c:lvl>
               </c:multiLvlStrCache>
@@ -849,10 +883,10 @@
           </c:cat>
           <c:val>
             <c:numRef>
-              <c:f>Sheet1!$B$2:$B$21</c:f>
+              <c:f>Sheet1!$B$2:$B$23</c:f>
               <c:numCache>
                 <c:formatCode>General</c:formatCode>
-                <c:ptCount val="20"/>
+                <c:ptCount val="22"/>
                 <c:pt idx="0">
                   <c:v>24200</c:v>
                 </c:pt>
@@ -911,7 +945,13 @@
                   <c:v>24150</c:v>
                 </c:pt>
                 <c:pt idx="19">
-                  <c:v>22950</c:v>
+                  <c:v>25200</c:v>
+                </c:pt>
+                <c:pt idx="20">
+                  <c:v>29700</c:v>
+                </c:pt>
+                <c:pt idx="21">
+                  <c:v>29600</c:v>
                 </c:pt>
               </c:numCache>
             </c:numRef>
@@ -989,9 +1029,9 @@
           </c:marker>
           <c:cat>
             <c:multiLvlStrRef>
-              <c:f>Sheet1!$A$2:$A$21</c:f>
+              <c:f>Sheet1!$A$2:$A$23</c:f>
               <c:multiLvlStrCache>
-                <c:ptCount val="20"/>
+                <c:ptCount val="22"/>
                 <c:lvl>
                   <c:pt idx="0">
                     <c:v>Dec'24</c:v>
@@ -1052,6 +1092,12 @@
                   </c:pt>
                   <c:pt idx="19">
                     <c:v>Jul'26</c:v>
+                  </c:pt>
+                  <c:pt idx="20">
+                    <c:v>Aug'26</c:v>
+                  </c:pt>
+                  <c:pt idx="21">
+                    <c:v>Sep'26</c:v>
                   </c:pt>
                 </c:lvl>
               </c:multiLvlStrCache>
@@ -1059,10 +1105,10 @@
           </c:cat>
           <c:val>
             <c:numRef>
-              <c:f>Sheet1!$C$2:$C$21</c:f>
+              <c:f>Sheet1!$C$2:$C$23</c:f>
               <c:numCache>
                 <c:formatCode>General</c:formatCode>
-                <c:ptCount val="20"/>
+                <c:ptCount val="22"/>
                 <c:pt idx="0">
                   <c:v>32550</c:v>
                 </c:pt>
@@ -1121,7 +1167,13 @@
                   <c:v>37150</c:v>
                 </c:pt>
                 <c:pt idx="19">
-                  <c:v>38000</c:v>
+                  <c:v>38800</c:v>
+                </c:pt>
+                <c:pt idx="20">
+                  <c:v>40000</c:v>
+                </c:pt>
+                <c:pt idx="21">
+                  <c:v>41700</c:v>
                 </c:pt>
               </c:numCache>
             </c:numRef>
@@ -1199,9 +1251,9 @@
           </c:marker>
           <c:cat>
             <c:multiLvlStrRef>
-              <c:f>Sheet1!$A$2:$A$21</c:f>
+              <c:f>Sheet1!$A$2:$A$23</c:f>
               <c:multiLvlStrCache>
-                <c:ptCount val="20"/>
+                <c:ptCount val="22"/>
                 <c:lvl>
                   <c:pt idx="0">
                     <c:v>Dec'24</c:v>
@@ -1262,6 +1314,12 @@
                   </c:pt>
                   <c:pt idx="19">
                     <c:v>Jul'26</c:v>
+                  </c:pt>
+                  <c:pt idx="20">
+                    <c:v>Aug'26</c:v>
+                  </c:pt>
+                  <c:pt idx="21">
+                    <c:v>Sep'26</c:v>
                   </c:pt>
                 </c:lvl>
               </c:multiLvlStrCache>
@@ -1269,10 +1327,10 @@
           </c:cat>
           <c:val>
             <c:numRef>
-              <c:f>Sheet1!$D$2:$D$21</c:f>
+              <c:f>Sheet1!$D$2:$D$23</c:f>
               <c:numCache>
                 <c:formatCode>General</c:formatCode>
-                <c:ptCount val="20"/>
+                <c:ptCount val="22"/>
                 <c:pt idx="0">
                   <c:v>28800</c:v>
                 </c:pt>
@@ -1331,7 +1389,13 @@
                   <c:v>28250</c:v>
                 </c:pt>
                 <c:pt idx="19">
-                  <c:v>26900</c:v>
+                  <c:v>29400</c:v>
+                </c:pt>
+                <c:pt idx="20">
+                  <c:v>33700</c:v>
+                </c:pt>
+                <c:pt idx="21">
+                  <c:v>33800</c:v>
                 </c:pt>
               </c:numCache>
             </c:numRef>
@@ -1409,9 +1473,9 @@
           </c:marker>
           <c:cat>
             <c:multiLvlStrRef>
-              <c:f>Sheet1!$A$2:$A$21</c:f>
+              <c:f>Sheet1!$A$2:$A$23</c:f>
               <c:multiLvlStrCache>
-                <c:ptCount val="20"/>
+                <c:ptCount val="22"/>
                 <c:lvl>
                   <c:pt idx="0">
                     <c:v>Dec'24</c:v>
@@ -1472,6 +1536,12 @@
                   </c:pt>
                   <c:pt idx="19">
                     <c:v>Jul'26</c:v>
+                  </c:pt>
+                  <c:pt idx="20">
+                    <c:v>Aug'26</c:v>
+                  </c:pt>
+                  <c:pt idx="21">
+                    <c:v>Sep'26</c:v>
                   </c:pt>
                 </c:lvl>
               </c:multiLvlStrCache>
@@ -1479,10 +1549,10 @@
           </c:cat>
           <c:val>
             <c:numRef>
-              <c:f>Sheet1!$E$2:$E$21</c:f>
+              <c:f>Sheet1!$E$2:$E$23</c:f>
               <c:numCache>
                 <c:formatCode>General</c:formatCode>
-                <c:ptCount val="20"/>
+                <c:ptCount val="22"/>
                 <c:pt idx="0">
                   <c:v>26200</c:v>
                 </c:pt>
@@ -1541,7 +1611,13 @@
                   <c:v>30880</c:v>
                 </c:pt>
                 <c:pt idx="19">
-                  <c:v>30000</c:v>
+                  <c:v>29839.999999999996</c:v>
+                </c:pt>
+                <c:pt idx="20">
+                  <c:v>29839.999999999996</c:v>
+                </c:pt>
+                <c:pt idx="21">
+                  <c:v>30800</c:v>
                 </c:pt>
               </c:numCache>
             </c:numRef>
@@ -1773,9 +1849,9 @@
           </c:dLbls>
           <c:cat>
             <c:multiLvlStrRef>
-              <c:f>Sheet1!$A$2:$A$21</c:f>
+              <c:f>Sheet1!$A$2:$A$23</c:f>
               <c:multiLvlStrCache>
-                <c:ptCount val="20"/>
+                <c:ptCount val="22"/>
                 <c:lvl>
                   <c:pt idx="0">
                     <c:v>Dec'24</c:v>
@@ -1854,7 +1930,15 @@
                   </c:pt>
                   <c:pt idx="19">
                     <c:v>Jul'26
-R:-516 | N:-67</c:v>
+R:-1,893 | N:-1,519</c:v>
+                  </c:pt>
+                  <c:pt idx="20">
+                    <c:v>Aug'26
+R:-630 | N:-461</c:v>
+                  </c:pt>
+                  <c:pt idx="21">
+                    <c:v>Sep'26
+R:+870 | N:+1,137</c:v>
                   </c:pt>
                 </c:lvl>
               </c:multiLvlStrCache>
@@ -1862,10 +1946,10 @@
           </c:cat>
           <c:val>
             <c:numRef>
-              <c:f>Sheet1!$B$2:$B$21</c:f>
+              <c:f>Sheet1!$B$2:$B$23</c:f>
               <c:numCache>
                 <c:formatCode>General</c:formatCode>
-                <c:ptCount val="20"/>
+                <c:ptCount val="22"/>
                 <c:pt idx="0">
                   <c:v>518.69</c:v>
                 </c:pt>
@@ -1924,7 +2008,13 @@
                   <c:v>213.13</c:v>
                 </c:pt>
                 <c:pt idx="19">
-                  <c:v>-302.61</c:v>
+                  <c:v>-1680.09</c:v>
+                </c:pt>
+                <c:pt idx="20">
+                  <c:v>-2309.77</c:v>
+                </c:pt>
+                <c:pt idx="21">
+                  <c:v>-1439.38</c:v>
                 </c:pt>
               </c:numCache>
             </c:numRef>
@@ -1977,9 +2067,9 @@
           </c:dLbls>
           <c:cat>
             <c:multiLvlStrRef>
-              <c:f>Sheet1!$A$2:$A$21</c:f>
+              <c:f>Sheet1!$A$2:$A$23</c:f>
               <c:multiLvlStrCache>
-                <c:ptCount val="20"/>
+                <c:ptCount val="22"/>
                 <c:lvl>
                   <c:pt idx="0">
                     <c:v>Dec'24</c:v>
@@ -2058,7 +2148,15 @@
                   </c:pt>
                   <c:pt idx="19">
                     <c:v>Jul'26
-R:-516 | N:-67</c:v>
+R:-1,893 | N:-1,519</c:v>
+                  </c:pt>
+                  <c:pt idx="20">
+                    <c:v>Aug'26
+R:-630 | N:-461</c:v>
+                  </c:pt>
+                  <c:pt idx="21">
+                    <c:v>Sep'26
+R:+870 | N:+1,137</c:v>
                   </c:pt>
                 </c:lvl>
               </c:multiLvlStrCache>
@@ -2066,10 +2164,10 @@
           </c:cat>
           <c:val>
             <c:numRef>
-              <c:f>Sheet1!$C$2:$C$21</c:f>
+              <c:f>Sheet1!$C$2:$C$23</c:f>
               <c:numCache>
                 <c:formatCode>General</c:formatCode>
-                <c:ptCount val="20"/>
+                <c:ptCount val="22"/>
                 <c:pt idx="0">
                   <c:v>85.71</c:v>
                 </c:pt>
@@ -2128,7 +2226,13 @@
                   <c:v>-78.78</c:v>
                 </c:pt>
                 <c:pt idx="19">
-                  <c:v>-145.94</c:v>
+                  <c:v>-1597.66</c:v>
+                </c:pt>
+                <c:pt idx="20">
+                  <c:v>-2059.16</c:v>
+                </c:pt>
+                <c:pt idx="21">
+                  <c:v>-922.1</c:v>
                 </c:pt>
               </c:numCache>
             </c:numRef>
@@ -2360,9 +2464,9 @@
           </c:dLbls>
           <c:cat>
             <c:multiLvlStrRef>
-              <c:f>Sheet1!$A$2:$A$21</c:f>
+              <c:f>Sheet1!$A$2:$A$23</c:f>
               <c:multiLvlStrCache>
-                <c:ptCount val="20"/>
+                <c:ptCount val="22"/>
                 <c:lvl>
                   <c:pt idx="0">
                     <c:v>Dec'24</c:v>
@@ -2441,7 +2545,15 @@
                   </c:pt>
                   <c:pt idx="19">
                     <c:v>Jul'26
-R:-1,157 | N:-1,756</c:v>
+R:-2,803 | N:-2,722</c:v>
+                  </c:pt>
+                  <c:pt idx="20">
+                    <c:v>Aug'26
+R:+932 | N:-299</c:v>
+                  </c:pt>
+                  <c:pt idx="21">
+                    <c:v>Sep'26
+R:+569 | N:+733</c:v>
                   </c:pt>
                 </c:lvl>
               </c:multiLvlStrCache>
@@ -2449,10 +2561,10 @@
           </c:cat>
           <c:val>
             <c:numRef>
-              <c:f>Sheet1!$B$2:$B$21</c:f>
+              <c:f>Sheet1!$B$2:$B$23</c:f>
               <c:numCache>
                 <c:formatCode>General</c:formatCode>
-                <c:ptCount val="20"/>
+                <c:ptCount val="22"/>
                 <c:pt idx="0">
                   <c:v>785.24</c:v>
                 </c:pt>
@@ -2511,7 +2623,13 @@
                   <c:v>22.04</c:v>
                 </c:pt>
                 <c:pt idx="19">
-                  <c:v>-1134.63</c:v>
+                  <c:v>-2780.73</c:v>
+                </c:pt>
+                <c:pt idx="20">
+                  <c:v>-1848.25</c:v>
+                </c:pt>
+                <c:pt idx="21">
+                  <c:v>-1279.7</c:v>
                 </c:pt>
               </c:numCache>
             </c:numRef>
@@ -2564,9 +2682,9 @@
           </c:dLbls>
           <c:cat>
             <c:multiLvlStrRef>
-              <c:f>Sheet1!$A$2:$A$21</c:f>
+              <c:f>Sheet1!$A$2:$A$23</c:f>
               <c:multiLvlStrCache>
-                <c:ptCount val="20"/>
+                <c:ptCount val="22"/>
                 <c:lvl>
                   <c:pt idx="0">
                     <c:v>Dec'24</c:v>
@@ -2645,7 +2763,15 @@
                   </c:pt>
                   <c:pt idx="19">
                     <c:v>Jul'26
-R:-1,157 | N:-1,756</c:v>
+R:-2,803 | N:-2,722</c:v>
+                  </c:pt>
+                  <c:pt idx="20">
+                    <c:v>Aug'26
+R:+932 | N:-299</c:v>
+                  </c:pt>
+                  <c:pt idx="21">
+                    <c:v>Sep'26
+R:+569 | N:+733</c:v>
                   </c:pt>
                 </c:lvl>
               </c:multiLvlStrCache>
@@ -2653,10 +2779,10 @@
           </c:cat>
           <c:val>
             <c:numRef>
-              <c:f>Sheet1!$C$2:$C$21</c:f>
+              <c:f>Sheet1!$C$2:$C$23</c:f>
               <c:numCache>
                 <c:formatCode>General</c:formatCode>
-                <c:ptCount val="20"/>
+                <c:ptCount val="22"/>
                 <c:pt idx="0">
                   <c:v>1176.79</c:v>
                 </c:pt>
@@ -2715,7 +2841,13 @@
                   <c:v>1198.99</c:v>
                 </c:pt>
                 <c:pt idx="19">
-                  <c:v>-557.51</c:v>
+                  <c:v>-1523.24</c:v>
+                </c:pt>
+                <c:pt idx="20">
+                  <c:v>-1822.03</c:v>
+                </c:pt>
+                <c:pt idx="21">
+                  <c:v>-1088.67</c:v>
                 </c:pt>
               </c:numCache>
             </c:numRef>
@@ -4193,7 +4325,7 @@
                 <a:ea typeface="Calibri" pitchFamily="34" charset="-122"/>
                 <a:cs typeface="Calibri" pitchFamily="34" charset="-120"/>
               </a:rPr>
-              <a:t>Period: 2024-12-12 to 2026-07-14  |  20 months</a:t>
+              <a:t>Period: 2024-12-12 to 2026-09-15  |  22 months</a:t>
             </a:r>
             <a:endParaRPr lang="en-US" sz="1200" dirty="0"/>
           </a:p>
@@ -4457,7 +4589,7 @@
                 <a:ea typeface="Calibri" pitchFamily="34" charset="-122"/>
                 <a:cs typeface="Calibri" pitchFamily="34" charset="-120"/>
               </a:rPr>
-              <a:t>Latest:  Raipur -300  |  NCR -1,600     •     Avg:  Raipur 32,653  |  NCR 32,990 INR/MT</a:t>
+              <a:t>Latest:  Raipur +500  |  NCR +500     •     Avg:  Raipur 33,034  |  NCR 33,600 INR/MT</a:t>
             </a:r>
             <a:endParaRPr lang="en-US" sz="1100" dirty="0"/>
           </a:p>
@@ -4760,7 +4892,7 @@
                 <a:ea typeface="Calibri" pitchFamily="34" charset="-122"/>
                 <a:cs typeface="Calibri" pitchFamily="34" charset="-120"/>
               </a:rPr>
-              <a:t>Latest change:  Pallet DRI: -1,200 INR/MT  |  Pig Iron: +850 INR/MT  |  Iron Ore DRI: -1,350 INR/MT  |  Silico Manganese: -2.2 INR/kg</a:t>
+              <a:t>Latest change:  Pallet DRI: -100 INR/MT  |  Pig Iron: +1,700 INR/MT  |  Iron Ore DRI: +100 INR/MT  |  Silico Manganese: +2.4 INR/kg</a:t>
             </a:r>
             <a:endParaRPr lang="en-US" sz="1100" dirty="0"/>
           </a:p>
@@ -5063,7 +5195,7 @@
                 <a:ea typeface="Calibri" pitchFamily="34" charset="-122"/>
                 <a:cs typeface="Calibri" pitchFamily="34" charset="-120"/>
               </a:rPr>
-              <a:t>Latest:  Raipur -516  |  NCR -67     •     Avg:  Raipur 58  |  NCR -125 INR/MT</a:t>
+              <a:t>Latest:  Raipur +870  |  NCR +1,137     •     Avg:  Raipur -180  |  NCR -315 INR/MT</a:t>
             </a:r>
             <a:endParaRPr lang="en-US" sz="1100" dirty="0"/>
           </a:p>
@@ -5366,7 +5498,7 @@
                 <a:ea typeface="Calibri" pitchFamily="34" charset="-122"/>
                 <a:cs typeface="Calibri" pitchFamily="34" charset="-120"/>
               </a:rPr>
-              <a:t>Latest:  Raipur -1,157  |  NCR -1,756     •     Avg:  Raipur 535  |  NCR 1,321 INR/MT</a:t>
+              <a:t>Latest:  Raipur +569  |  NCR +733     •     Avg:  Raipur 270  |  NCR 1,025 INR/MT</a:t>
             </a:r>
             <a:endParaRPr lang="en-US" sz="1100" dirty="0"/>
           </a:p>

</xml_diff>

<commit_message>
Regenerate material change graphs for 2026-09-23 update
Co-Authored-By: Claude Opus 5.5 <noreply@anthropic.com>
Claude-Session: https://claude.ai/code/session_01MztwMJnz2CCbYvjHcZqkdz
</commit_message>
<xml_diff>
--- a/output/material_change_graphs.pptx
+++ b/output/material_change_graphs.pptx
@@ -259,7 +259,7 @@
                   </c:pt>
                   <c:pt idx="21">
                     <c:v>Sep'26
-R:+500 | N:+500</c:v>
+R:+900 | N:-1,100</c:v>
                   </c:pt>
                 </c:lvl>
               </c:multiLvlStrCache>
@@ -335,7 +335,7 @@
                   <c:v>36500</c:v>
                 </c:pt>
                 <c:pt idx="21">
-                  <c:v>37000</c:v>
+                  <c:v>37400</c:v>
                 </c:pt>
               </c:numCache>
             </c:numRef>
@@ -477,7 +477,7 @@
                   </c:pt>
                   <c:pt idx="21">
                     <c:v>Sep'26
-R:+500 | N:+500</c:v>
+R:+900 | N:-1,100</c:v>
                   </c:pt>
                 </c:lvl>
               </c:multiLvlStrCache>
@@ -553,7 +553,7 @@
                   <c:v>38900</c:v>
                 </c:pt>
                 <c:pt idx="21">
-                  <c:v>39400</c:v>
+                  <c:v>37800</c:v>
                 </c:pt>
               </c:numCache>
             </c:numRef>
@@ -951,7 +951,7 @@
                   <c:v>29700</c:v>
                 </c:pt>
                 <c:pt idx="21">
-                  <c:v>29600</c:v>
+                  <c:v>28100</c:v>
                 </c:pt>
               </c:numCache>
             </c:numRef>
@@ -1173,7 +1173,7 @@
                   <c:v>40000</c:v>
                 </c:pt>
                 <c:pt idx="21">
-                  <c:v>41700</c:v>
+                  <c:v>41950</c:v>
                 </c:pt>
               </c:numCache>
             </c:numRef>
@@ -1395,7 +1395,7 @@
                   <c:v>33700</c:v>
                 </c:pt>
                 <c:pt idx="21">
-                  <c:v>33800</c:v>
+                  <c:v>32350</c:v>
                 </c:pt>
               </c:numCache>
             </c:numRef>
@@ -1617,7 +1617,7 @@
                   <c:v>29839.999999999996</c:v>
                 </c:pt>
                 <c:pt idx="21">
-                  <c:v>30800</c:v>
+                  <c:v>31439.999999999996</c:v>
                 </c:pt>
               </c:numCache>
             </c:numRef>
@@ -1938,7 +1938,7 @@
                   </c:pt>
                   <c:pt idx="21">
                     <c:v>Sep'26
-R:+870 | N:+1,137</c:v>
+R:+2,622 | N:+2,088</c:v>
                   </c:pt>
                 </c:lvl>
               </c:multiLvlStrCache>
@@ -2014,7 +2014,7 @@
                   <c:v>-2309.77</c:v>
                 </c:pt>
                 <c:pt idx="21">
-                  <c:v>-1439.38</c:v>
+                  <c:v>312.26</c:v>
                 </c:pt>
               </c:numCache>
             </c:numRef>
@@ -2156,7 +2156,7 @@
                   </c:pt>
                   <c:pt idx="21">
                     <c:v>Sep'26
-R:+870 | N:+1,137</c:v>
+R:+2,622 | N:+2,088</c:v>
                   </c:pt>
                 </c:lvl>
               </c:multiLvlStrCache>
@@ -2232,7 +2232,7 @@
                   <c:v>-2059.16</c:v>
                 </c:pt>
                 <c:pt idx="21">
-                  <c:v>-922.1</c:v>
+                  <c:v>28.44</c:v>
                 </c:pt>
               </c:numCache>
             </c:numRef>
@@ -2553,7 +2553,7 @@
                   </c:pt>
                   <c:pt idx="21">
                     <c:v>Sep'26
-R:+569 | N:+733</c:v>
+R:+2,531 | N:+2,046</c:v>
                   </c:pt>
                 </c:lvl>
               </c:multiLvlStrCache>
@@ -2629,7 +2629,7 @@
                   <c:v>-1848.25</c:v>
                 </c:pt>
                 <c:pt idx="21">
-                  <c:v>-1279.7</c:v>
+                  <c:v>682.76</c:v>
                 </c:pt>
               </c:numCache>
             </c:numRef>
@@ -2771,7 +2771,7 @@
                   </c:pt>
                   <c:pt idx="21">
                     <c:v>Sep'26
-R:+569 | N:+733</c:v>
+R:+2,531 | N:+2,046</c:v>
                   </c:pt>
                 </c:lvl>
               </c:multiLvlStrCache>
@@ -2847,7 +2847,7 @@
                   <c:v>-1822.03</c:v>
                 </c:pt>
                 <c:pt idx="21">
-                  <c:v>-1088.67</c:v>
+                  <c:v>223.87</c:v>
                 </c:pt>
               </c:numCache>
             </c:numRef>
@@ -4325,7 +4325,7 @@
                 <a:ea typeface="Calibri" pitchFamily="34" charset="-122"/>
                 <a:cs typeface="Calibri" pitchFamily="34" charset="-120"/>
               </a:rPr>
-              <a:t>Period: 2024-12-12 to 2026-09-15  |  22 months</a:t>
+              <a:t>Period: 2024-12-12 to 2026-09-23  |  22 months</a:t>
             </a:r>
             <a:endParaRPr lang="en-US" sz="1200" dirty="0"/>
           </a:p>
@@ -4589,7 +4589,7 @@
                 <a:ea typeface="Calibri" pitchFamily="34" charset="-122"/>
                 <a:cs typeface="Calibri" pitchFamily="34" charset="-120"/>
               </a:rPr>
-              <a:t>Latest:  Raipur +500  |  NCR +500     •     Avg:  Raipur 33,034  |  NCR 33,600 INR/MT</a:t>
+              <a:t>Latest:  Raipur +900  |  NCR -1,100     •     Avg:  Raipur 33,052  |  NCR 33,527 INR/MT</a:t>
             </a:r>
             <a:endParaRPr lang="en-US" sz="1100" dirty="0"/>
           </a:p>
@@ -4892,7 +4892,7 @@
                 <a:ea typeface="Calibri" pitchFamily="34" charset="-122"/>
                 <a:cs typeface="Calibri" pitchFamily="34" charset="-120"/>
               </a:rPr>
-              <a:t>Latest change:  Pallet DRI: -100 INR/MT  |  Pig Iron: +1,700 INR/MT  |  Iron Ore DRI: +100 INR/MT  |  Silico Manganese: +2.4 INR/kg</a:t>
+              <a:t>Latest change:  Pallet DRI: -1,600 INR/MT  |  Pig Iron: +1,950 INR/MT  |  Iron Ore DRI: -1,350 INR/MT  |  Silico Manganese: +4.0 INR/kg</a:t>
             </a:r>
             <a:endParaRPr lang="en-US" sz="1100" dirty="0"/>
           </a:p>
@@ -5195,7 +5195,7 @@
                 <a:ea typeface="Calibri" pitchFamily="34" charset="-122"/>
                 <a:cs typeface="Calibri" pitchFamily="34" charset="-120"/>
               </a:rPr>
-              <a:t>Latest:  Raipur +870  |  NCR +1,137     •     Avg:  Raipur -180  |  NCR -315 INR/MT</a:t>
+              <a:t>Latest:  Raipur +2,622  |  NCR +2,088     •     Avg:  Raipur -100  |  NCR -272 INR/MT</a:t>
             </a:r>
             <a:endParaRPr lang="en-US" sz="1100" dirty="0"/>
           </a:p>
@@ -5498,7 +5498,7 @@
                 <a:ea typeface="Calibri" pitchFamily="34" charset="-122"/>
                 <a:cs typeface="Calibri" pitchFamily="34" charset="-120"/>
               </a:rPr>
-              <a:t>Latest:  Raipur +569  |  NCR +733     •     Avg:  Raipur 270  |  NCR 1,025 INR/MT</a:t>
+              <a:t>Latest:  Raipur +2,531  |  NCR +2,046     •     Avg:  Raipur 359  |  NCR 1,084 INR/MT</a:t>
             </a:r>
             <a:endParaRPr lang="en-US" sz="1100" dirty="0"/>
           </a:p>

</xml_diff>

<commit_message>
Regenerate material change graphs through 2026-09-30
Co-Authored-By: Claude Opus 5.5 <noreply@anthropic.com>
Claude-Session: https://claude.ai/code/session_01Gu2fT9tcN6RLRpeLmzhU16
</commit_message>
<xml_diff>
--- a/output/material_change_graphs.pptx
+++ b/output/material_change_graphs.pptx
@@ -259,7 +259,7 @@
                   </c:pt>
                   <c:pt idx="21">
                     <c:v>Sep'26
-R:+500 | N:+500</c:v>
+R:+1,900 | N:+300</c:v>
                   </c:pt>
                 </c:lvl>
               </c:multiLvlStrCache>
@@ -335,7 +335,7 @@
                   <c:v>36500</c:v>
                 </c:pt>
                 <c:pt idx="21">
-                  <c:v>37000</c:v>
+                  <c:v>38400</c:v>
                 </c:pt>
               </c:numCache>
             </c:numRef>
@@ -477,7 +477,7 @@
                   </c:pt>
                   <c:pt idx="21">
                     <c:v>Sep'26
-R:+500 | N:+500</c:v>
+R:+1,900 | N:+300</c:v>
                   </c:pt>
                 </c:lvl>
               </c:multiLvlStrCache>
@@ -553,7 +553,7 @@
                   <c:v>38900</c:v>
                 </c:pt>
                 <c:pt idx="21">
-                  <c:v>39400</c:v>
+                  <c:v>39200</c:v>
                 </c:pt>
               </c:numCache>
             </c:numRef>
@@ -951,7 +951,7 @@
                   <c:v>29700</c:v>
                 </c:pt>
                 <c:pt idx="21">
-                  <c:v>29600</c:v>
+                  <c:v>29300</c:v>
                 </c:pt>
               </c:numCache>
             </c:numRef>
@@ -1173,7 +1173,7 @@
                   <c:v>40000</c:v>
                 </c:pt>
                 <c:pt idx="21">
-                  <c:v>41700</c:v>
+                  <c:v>42700</c:v>
                 </c:pt>
               </c:numCache>
             </c:numRef>
@@ -1395,7 +1395,7 @@
                   <c:v>33700</c:v>
                 </c:pt>
                 <c:pt idx="21">
-                  <c:v>33800</c:v>
+                  <c:v>34100</c:v>
                 </c:pt>
               </c:numCache>
             </c:numRef>
@@ -1617,7 +1617,7 @@
                   <c:v>29839.999999999996</c:v>
                 </c:pt>
                 <c:pt idx="21">
-                  <c:v>30800</c:v>
+                  <c:v>32720</c:v>
                 </c:pt>
               </c:numCache>
             </c:numRef>
@@ -1938,7 +1938,7 @@
                   </c:pt>
                   <c:pt idx="21">
                     <c:v>Sep'26
-R:+870 | N:+1,137</c:v>
+R:+2,399 | N:+1,791</c:v>
                   </c:pt>
                 </c:lvl>
               </c:multiLvlStrCache>
@@ -2014,7 +2014,7 @@
                   <c:v>-2309.77</c:v>
                 </c:pt>
                 <c:pt idx="21">
-                  <c:v>-1439.38</c:v>
+                  <c:v>89.21</c:v>
                 </c:pt>
               </c:numCache>
             </c:numRef>
@@ -2156,7 +2156,7 @@
                   </c:pt>
                   <c:pt idx="21">
                     <c:v>Sep'26
-R:+870 | N:+1,137</c:v>
+R:+2,399 | N:+1,791</c:v>
                   </c:pt>
                 </c:lvl>
               </c:multiLvlStrCache>
@@ -2232,7 +2232,7 @@
                   <c:v>-2059.16</c:v>
                 </c:pt>
                 <c:pt idx="21">
-                  <c:v>-922.1</c:v>
+                  <c:v>-268.49</c:v>
                 </c:pt>
               </c:numCache>
             </c:numRef>
@@ -2553,7 +2553,7 @@
                   </c:pt>
                   <c:pt idx="21">
                     <c:v>Sep'26
-R:+569 | N:+733</c:v>
+R:+2,246 | N:+2,887</c:v>
                   </c:pt>
                 </c:lvl>
               </c:multiLvlStrCache>
@@ -2629,7 +2629,7 @@
                   <c:v>-1848.25</c:v>
                 </c:pt>
                 <c:pt idx="21">
-                  <c:v>-1279.7</c:v>
+                  <c:v>397.93</c:v>
                 </c:pt>
               </c:numCache>
             </c:numRef>
@@ -2771,7 +2771,7 @@
                   </c:pt>
                   <c:pt idx="21">
                     <c:v>Sep'26
-R:+569 | N:+733</c:v>
+R:+2,246 | N:+2,887</c:v>
                   </c:pt>
                 </c:lvl>
               </c:multiLvlStrCache>
@@ -2847,7 +2847,7 @@
                   <c:v>-1822.03</c:v>
                 </c:pt>
                 <c:pt idx="21">
-                  <c:v>-1088.67</c:v>
+                  <c:v>1065.37</c:v>
                 </c:pt>
               </c:numCache>
             </c:numRef>
@@ -4325,7 +4325,7 @@
                 <a:ea typeface="Calibri" pitchFamily="34" charset="-122"/>
                 <a:cs typeface="Calibri" pitchFamily="34" charset="-120"/>
               </a:rPr>
-              <a:t>Period: 2024-12-12 to 2026-09-15  |  22 months</a:t>
+              <a:t>Period: 2024-12-12 to 2026-09-30  |  22 months</a:t>
             </a:r>
             <a:endParaRPr lang="en-US" sz="1200" dirty="0"/>
           </a:p>
@@ -4589,7 +4589,7 @@
                 <a:ea typeface="Calibri" pitchFamily="34" charset="-122"/>
                 <a:cs typeface="Calibri" pitchFamily="34" charset="-120"/>
               </a:rPr>
-              <a:t>Latest:  Raipur +500  |  NCR +500     •     Avg:  Raipur 33,034  |  NCR 33,600 INR/MT</a:t>
+              <a:t>Latest:  Raipur +1,900  |  NCR +300     •     Avg:  Raipur 33,098  |  NCR 33,591 INR/MT</a:t>
             </a:r>
             <a:endParaRPr lang="en-US" sz="1100" dirty="0"/>
           </a:p>
@@ -4892,7 +4892,7 @@
                 <a:ea typeface="Calibri" pitchFamily="34" charset="-122"/>
                 <a:cs typeface="Calibri" pitchFamily="34" charset="-120"/>
               </a:rPr>
-              <a:t>Latest change:  Pallet DRI: -100 INR/MT  |  Pig Iron: +1,700 INR/MT  |  Iron Ore DRI: +100 INR/MT  |  Silico Manganese: +2.4 INR/kg</a:t>
+              <a:t>Latest change:  Pallet DRI: -400 INR/MT  |  Pig Iron: +2,700 INR/MT  |  Iron Ore DRI: +400 INR/MT  |  Silico Manganese: +7.2 INR/kg</a:t>
             </a:r>
             <a:endParaRPr lang="en-US" sz="1100" dirty="0"/>
           </a:p>
@@ -5195,7 +5195,7 @@
                 <a:ea typeface="Calibri" pitchFamily="34" charset="-122"/>
                 <a:cs typeface="Calibri" pitchFamily="34" charset="-120"/>
               </a:rPr>
-              <a:t>Latest:  Raipur +870  |  NCR +1,137     •     Avg:  Raipur -180  |  NCR -315 INR/MT</a:t>
+              <a:t>Latest:  Raipur +2,399  |  NCR +1,791     •     Avg:  Raipur -111  |  NCR -285 INR/MT</a:t>
             </a:r>
             <a:endParaRPr lang="en-US" sz="1100" dirty="0"/>
           </a:p>
@@ -5498,7 +5498,7 @@
                 <a:ea typeface="Calibri" pitchFamily="34" charset="-122"/>
                 <a:cs typeface="Calibri" pitchFamily="34" charset="-120"/>
               </a:rPr>
-              <a:t>Latest:  Raipur +569  |  NCR +733     •     Avg:  Raipur 270  |  NCR 1,025 INR/MT</a:t>
+              <a:t>Latest:  Raipur +2,246  |  NCR +2,887     •     Avg:  Raipur 346  |  NCR 1,123 INR/MT</a:t>
             </a:r>
             <a:endParaRPr lang="en-US" sz="1100" dirty="0"/>
           </a:p>

</xml_diff>

<commit_message>
Regenerate material change graphs through 2026-10-07
Co-Authored-By: Claude Opus 5.5 <noreply@anthropic.com>
Claude-Session: https://claude.ai/code/session_01Gu2fT9tcN6RLRpeLmzhU16
</commit_message>
<xml_diff>
--- a/output/material_change_graphs.pptx
+++ b/output/material_change_graphs.pptx
@@ -170,9 +170,9 @@
           </c:dLbls>
           <c:cat>
             <c:multiLvlStrRef>
-              <c:f>Sheet1!$A$2:$A$23</c:f>
+              <c:f>Sheet1!$A$2:$A$24</c:f>
               <c:multiLvlStrCache>
-                <c:ptCount val="22"/>
+                <c:ptCount val="23"/>
                 <c:lvl>
                   <c:pt idx="0">
                     <c:v>Dec'24</c:v>
@@ -260,6 +260,10 @@
                   <c:pt idx="21">
                     <c:v>Sep'26
 R:+1,900 | N:+300</c:v>
+                  </c:pt>
+                  <c:pt idx="22">
+                    <c:v>Oct'26
+R:+0.00 | N:+300</c:v>
                   </c:pt>
                 </c:lvl>
               </c:multiLvlStrCache>
@@ -267,10 +271,10 @@
           </c:cat>
           <c:val>
             <c:numRef>
-              <c:f>Sheet1!$B$2:$B$23</c:f>
+              <c:f>Sheet1!$B$2:$B$24</c:f>
               <c:numCache>
                 <c:formatCode>General</c:formatCode>
-                <c:ptCount val="22"/>
+                <c:ptCount val="23"/>
                 <c:pt idx="0">
                   <c:v>31300</c:v>
                 </c:pt>
@@ -335,6 +339,9 @@
                   <c:v>36500</c:v>
                 </c:pt>
                 <c:pt idx="21">
+                  <c:v>38400</c:v>
+                </c:pt>
+                <c:pt idx="22">
                   <c:v>38400</c:v>
                 </c:pt>
               </c:numCache>
@@ -388,9 +395,9 @@
           </c:dLbls>
           <c:cat>
             <c:multiLvlStrRef>
-              <c:f>Sheet1!$A$2:$A$23</c:f>
+              <c:f>Sheet1!$A$2:$A$24</c:f>
               <c:multiLvlStrCache>
-                <c:ptCount val="22"/>
+                <c:ptCount val="23"/>
                 <c:lvl>
                   <c:pt idx="0">
                     <c:v>Dec'24</c:v>
@@ -478,6 +485,10 @@
                   <c:pt idx="21">
                     <c:v>Sep'26
 R:+1,900 | N:+300</c:v>
+                  </c:pt>
+                  <c:pt idx="22">
+                    <c:v>Oct'26
+R:+0.00 | N:+300</c:v>
                   </c:pt>
                 </c:lvl>
               </c:multiLvlStrCache>
@@ -485,10 +496,10 @@
           </c:cat>
           <c:val>
             <c:numRef>
-              <c:f>Sheet1!$C$2:$C$23</c:f>
+              <c:f>Sheet1!$C$2:$C$24</c:f>
               <c:numCache>
                 <c:formatCode>General</c:formatCode>
-                <c:ptCount val="22"/>
+                <c:ptCount val="23"/>
                 <c:pt idx="0">
                   <c:v>33100</c:v>
                 </c:pt>
@@ -554,6 +565,9 @@
                 </c:pt>
                 <c:pt idx="21">
                   <c:v>39200</c:v>
+                </c:pt>
+                <c:pt idx="22">
+                  <c:v>39500</c:v>
                 </c:pt>
               </c:numCache>
             </c:numRef>
@@ -807,9 +821,9 @@
           </c:marker>
           <c:cat>
             <c:multiLvlStrRef>
-              <c:f>Sheet1!$A$2:$A$23</c:f>
+              <c:f>Sheet1!$A$2:$A$24</c:f>
               <c:multiLvlStrCache>
-                <c:ptCount val="22"/>
+                <c:ptCount val="23"/>
                 <c:lvl>
                   <c:pt idx="0">
                     <c:v>Dec'24</c:v>
@@ -876,6 +890,9 @@
                   </c:pt>
                   <c:pt idx="21">
                     <c:v>Sep'26</c:v>
+                  </c:pt>
+                  <c:pt idx="22">
+                    <c:v>Oct'26</c:v>
                   </c:pt>
                 </c:lvl>
               </c:multiLvlStrCache>
@@ -883,10 +900,10 @@
           </c:cat>
           <c:val>
             <c:numRef>
-              <c:f>Sheet1!$B$2:$B$23</c:f>
+              <c:f>Sheet1!$B$2:$B$24</c:f>
               <c:numCache>
                 <c:formatCode>General</c:formatCode>
-                <c:ptCount val="22"/>
+                <c:ptCount val="23"/>
                 <c:pt idx="0">
                   <c:v>24200</c:v>
                 </c:pt>
@@ -952,6 +969,9 @@
                 </c:pt>
                 <c:pt idx="21">
                   <c:v>29300</c:v>
+                </c:pt>
+                <c:pt idx="22">
+                  <c:v>29350</c:v>
                 </c:pt>
               </c:numCache>
             </c:numRef>
@@ -1029,9 +1049,9 @@
           </c:marker>
           <c:cat>
             <c:multiLvlStrRef>
-              <c:f>Sheet1!$A$2:$A$23</c:f>
+              <c:f>Sheet1!$A$2:$A$24</c:f>
               <c:multiLvlStrCache>
-                <c:ptCount val="22"/>
+                <c:ptCount val="23"/>
                 <c:lvl>
                   <c:pt idx="0">
                     <c:v>Dec'24</c:v>
@@ -1098,6 +1118,9 @@
                   </c:pt>
                   <c:pt idx="21">
                     <c:v>Sep'26</c:v>
+                  </c:pt>
+                  <c:pt idx="22">
+                    <c:v>Oct'26</c:v>
                   </c:pt>
                 </c:lvl>
               </c:multiLvlStrCache>
@@ -1105,10 +1128,10 @@
           </c:cat>
           <c:val>
             <c:numRef>
-              <c:f>Sheet1!$C$2:$C$23</c:f>
+              <c:f>Sheet1!$C$2:$C$24</c:f>
               <c:numCache>
                 <c:formatCode>General</c:formatCode>
-                <c:ptCount val="22"/>
+                <c:ptCount val="23"/>
                 <c:pt idx="0">
                   <c:v>32550</c:v>
                 </c:pt>
@@ -1174,6 +1197,9 @@
                 </c:pt>
                 <c:pt idx="21">
                   <c:v>42700</c:v>
+                </c:pt>
+                <c:pt idx="22">
+                  <c:v>43000</c:v>
                 </c:pt>
               </c:numCache>
             </c:numRef>
@@ -1251,9 +1277,9 @@
           </c:marker>
           <c:cat>
             <c:multiLvlStrRef>
-              <c:f>Sheet1!$A$2:$A$23</c:f>
+              <c:f>Sheet1!$A$2:$A$24</c:f>
               <c:multiLvlStrCache>
-                <c:ptCount val="22"/>
+                <c:ptCount val="23"/>
                 <c:lvl>
                   <c:pt idx="0">
                     <c:v>Dec'24</c:v>
@@ -1320,6 +1346,9 @@
                   </c:pt>
                   <c:pt idx="21">
                     <c:v>Sep'26</c:v>
+                  </c:pt>
+                  <c:pt idx="22">
+                    <c:v>Oct'26</c:v>
                   </c:pt>
                 </c:lvl>
               </c:multiLvlStrCache>
@@ -1327,10 +1356,10 @@
           </c:cat>
           <c:val>
             <c:numRef>
-              <c:f>Sheet1!$D$2:$D$23</c:f>
+              <c:f>Sheet1!$D$2:$D$24</c:f>
               <c:numCache>
                 <c:formatCode>General</c:formatCode>
-                <c:ptCount val="22"/>
+                <c:ptCount val="23"/>
                 <c:pt idx="0">
                   <c:v>28800</c:v>
                 </c:pt>
@@ -1396,6 +1425,9 @@
                 </c:pt>
                 <c:pt idx="21">
                   <c:v>34100</c:v>
+                </c:pt>
+                <c:pt idx="22">
+                  <c:v>34000</c:v>
                 </c:pt>
               </c:numCache>
             </c:numRef>
@@ -1473,9 +1505,9 @@
           </c:marker>
           <c:cat>
             <c:multiLvlStrRef>
-              <c:f>Sheet1!$A$2:$A$23</c:f>
+              <c:f>Sheet1!$A$2:$A$24</c:f>
               <c:multiLvlStrCache>
-                <c:ptCount val="22"/>
+                <c:ptCount val="23"/>
                 <c:lvl>
                   <c:pt idx="0">
                     <c:v>Dec'24</c:v>
@@ -1542,6 +1574,9 @@
                   </c:pt>
                   <c:pt idx="21">
                     <c:v>Sep'26</c:v>
+                  </c:pt>
+                  <c:pt idx="22">
+                    <c:v>Oct'26</c:v>
                   </c:pt>
                 </c:lvl>
               </c:multiLvlStrCache>
@@ -1549,10 +1584,10 @@
           </c:cat>
           <c:val>
             <c:numRef>
-              <c:f>Sheet1!$E$2:$E$23</c:f>
+              <c:f>Sheet1!$E$2:$E$24</c:f>
               <c:numCache>
                 <c:formatCode>General</c:formatCode>
-                <c:ptCount val="22"/>
+                <c:ptCount val="23"/>
                 <c:pt idx="0">
                   <c:v>26200</c:v>
                 </c:pt>
@@ -1618,6 +1653,9 @@
                 </c:pt>
                 <c:pt idx="21">
                   <c:v>32720</c:v>
+                </c:pt>
+                <c:pt idx="22">
+                  <c:v>33760</c:v>
                 </c:pt>
               </c:numCache>
             </c:numRef>
@@ -1849,9 +1887,9 @@
           </c:dLbls>
           <c:cat>
             <c:multiLvlStrRef>
-              <c:f>Sheet1!$A$2:$A$23</c:f>
+              <c:f>Sheet1!$A$2:$A$24</c:f>
               <c:multiLvlStrCache>
-                <c:ptCount val="22"/>
+                <c:ptCount val="23"/>
                 <c:lvl>
                   <c:pt idx="0">
                     <c:v>Dec'24</c:v>
@@ -1939,6 +1977,10 @@
                   <c:pt idx="21">
                     <c:v>Sep'26
 R:+2,399 | N:+1,791</c:v>
+                  </c:pt>
+                  <c:pt idx="22">
+                    <c:v>Oct'26
+R:+395 | N:-55</c:v>
                   </c:pt>
                 </c:lvl>
               </c:multiLvlStrCache>
@@ -1946,10 +1988,10 @@
           </c:cat>
           <c:val>
             <c:numRef>
-              <c:f>Sheet1!$B$2:$B$23</c:f>
+              <c:f>Sheet1!$B$2:$B$24</c:f>
               <c:numCache>
                 <c:formatCode>General</c:formatCode>
-                <c:ptCount val="22"/>
+                <c:ptCount val="23"/>
                 <c:pt idx="0">
                   <c:v>518.69</c:v>
                 </c:pt>
@@ -2015,6 +2057,9 @@
                 </c:pt>
                 <c:pt idx="21">
                   <c:v>89.21</c:v>
+                </c:pt>
+                <c:pt idx="22">
+                  <c:v>483.92</c:v>
                 </c:pt>
               </c:numCache>
             </c:numRef>
@@ -2067,9 +2112,9 @@
           </c:dLbls>
           <c:cat>
             <c:multiLvlStrRef>
-              <c:f>Sheet1!$A$2:$A$23</c:f>
+              <c:f>Sheet1!$A$2:$A$24</c:f>
               <c:multiLvlStrCache>
-                <c:ptCount val="22"/>
+                <c:ptCount val="23"/>
                 <c:lvl>
                   <c:pt idx="0">
                     <c:v>Dec'24</c:v>
@@ -2157,6 +2202,10 @@
                   <c:pt idx="21">
                     <c:v>Sep'26
 R:+2,399 | N:+1,791</c:v>
+                  </c:pt>
+                  <c:pt idx="22">
+                    <c:v>Oct'26
+R:+395 | N:-55</c:v>
                   </c:pt>
                 </c:lvl>
               </c:multiLvlStrCache>
@@ -2164,10 +2213,10 @@
           </c:cat>
           <c:val>
             <c:numRef>
-              <c:f>Sheet1!$C$2:$C$23</c:f>
+              <c:f>Sheet1!$C$2:$C$24</c:f>
               <c:numCache>
                 <c:formatCode>General</c:formatCode>
-                <c:ptCount val="22"/>
+                <c:ptCount val="23"/>
                 <c:pt idx="0">
                   <c:v>85.71</c:v>
                 </c:pt>
@@ -2233,6 +2282,9 @@
                 </c:pt>
                 <c:pt idx="21">
                   <c:v>-268.49</c:v>
+                </c:pt>
+                <c:pt idx="22">
+                  <c:v>-323.48</c:v>
                 </c:pt>
               </c:numCache>
             </c:numRef>
@@ -2464,9 +2516,9 @@
           </c:dLbls>
           <c:cat>
             <c:multiLvlStrRef>
-              <c:f>Sheet1!$A$2:$A$23</c:f>
+              <c:f>Sheet1!$A$2:$A$24</c:f>
               <c:multiLvlStrCache>
-                <c:ptCount val="22"/>
+                <c:ptCount val="23"/>
                 <c:lvl>
                   <c:pt idx="0">
                     <c:v>Dec'24</c:v>
@@ -2554,6 +2606,10 @@
                   <c:pt idx="21">
                     <c:v>Sep'26
 R:+2,246 | N:+2,887</c:v>
+                  </c:pt>
+                  <c:pt idx="22">
+                    <c:v>Oct'26
+R:+494 | N:+843</c:v>
                   </c:pt>
                 </c:lvl>
               </c:multiLvlStrCache>
@@ -2561,10 +2617,10 @@
           </c:cat>
           <c:val>
             <c:numRef>
-              <c:f>Sheet1!$B$2:$B$23</c:f>
+              <c:f>Sheet1!$B$2:$B$24</c:f>
               <c:numCache>
                 <c:formatCode>General</c:formatCode>
-                <c:ptCount val="22"/>
+                <c:ptCount val="23"/>
                 <c:pt idx="0">
                   <c:v>785.24</c:v>
                 </c:pt>
@@ -2630,6 +2686,9 @@
                 </c:pt>
                 <c:pt idx="21">
                   <c:v>397.93</c:v>
+                </c:pt>
+                <c:pt idx="22">
+                  <c:v>891.79</c:v>
                 </c:pt>
               </c:numCache>
             </c:numRef>
@@ -2682,9 +2741,9 @@
           </c:dLbls>
           <c:cat>
             <c:multiLvlStrRef>
-              <c:f>Sheet1!$A$2:$A$23</c:f>
+              <c:f>Sheet1!$A$2:$A$24</c:f>
               <c:multiLvlStrCache>
-                <c:ptCount val="22"/>
+                <c:ptCount val="23"/>
                 <c:lvl>
                   <c:pt idx="0">
                     <c:v>Dec'24</c:v>
@@ -2772,6 +2831,10 @@
                   <c:pt idx="21">
                     <c:v>Sep'26
 R:+2,246 | N:+2,887</c:v>
+                  </c:pt>
+                  <c:pt idx="22">
+                    <c:v>Oct'26
+R:+494 | N:+843</c:v>
                   </c:pt>
                 </c:lvl>
               </c:multiLvlStrCache>
@@ -2779,10 +2842,10 @@
           </c:cat>
           <c:val>
             <c:numRef>
-              <c:f>Sheet1!$C$2:$C$23</c:f>
+              <c:f>Sheet1!$C$2:$C$24</c:f>
               <c:numCache>
                 <c:formatCode>General</c:formatCode>
-                <c:ptCount val="22"/>
+                <c:ptCount val="23"/>
                 <c:pt idx="0">
                   <c:v>1176.79</c:v>
                 </c:pt>
@@ -2848,6 +2911,9 @@
                 </c:pt>
                 <c:pt idx="21">
                   <c:v>1065.37</c:v>
+                </c:pt>
+                <c:pt idx="22">
+                  <c:v>1908.33</c:v>
                 </c:pt>
               </c:numCache>
             </c:numRef>
@@ -4325,7 +4391,7 @@
                 <a:ea typeface="Calibri" pitchFamily="34" charset="-122"/>
                 <a:cs typeface="Calibri" pitchFamily="34" charset="-120"/>
               </a:rPr>
-              <a:t>Period: 2024-12-12 to 2026-09-30  |  22 months</a:t>
+              <a:t>Period: 2024-12-12 to 2026-10-07  |  23 months</a:t>
             </a:r>
             <a:endParaRPr lang="en-US" sz="1200" dirty="0"/>
           </a:p>
@@ -4589,7 +4655,7 @@
                 <a:ea typeface="Calibri" pitchFamily="34" charset="-122"/>
                 <a:cs typeface="Calibri" pitchFamily="34" charset="-120"/>
               </a:rPr>
-              <a:t>Latest:  Raipur +1,900  |  NCR +300     •     Avg:  Raipur 33,098  |  NCR 33,591 INR/MT</a:t>
+              <a:t>Latest:  Raipur +0.00  |  NCR +300     •     Avg:  Raipur 33,328  |  NCR 33,848 INR/MT</a:t>
             </a:r>
             <a:endParaRPr lang="en-US" sz="1100" dirty="0"/>
           </a:p>
@@ -4892,7 +4958,7 @@
                 <a:ea typeface="Calibri" pitchFamily="34" charset="-122"/>
                 <a:cs typeface="Calibri" pitchFamily="34" charset="-120"/>
               </a:rPr>
-              <a:t>Latest change:  Pallet DRI: -400 INR/MT  |  Pig Iron: +2,700 INR/MT  |  Iron Ore DRI: +400 INR/MT  |  Silico Manganese: +7.2 INR/kg</a:t>
+              <a:t>Latest change:  Pallet DRI: +50 INR/MT  |  Pig Iron: +300 INR/MT  |  Iron Ore DRI: -100 INR/MT  |  Silico Manganese: +2.6 INR/kg</a:t>
             </a:r>
             <a:endParaRPr lang="en-US" sz="1100" dirty="0"/>
           </a:p>
@@ -5195,7 +5261,7 @@
                 <a:ea typeface="Calibri" pitchFamily="34" charset="-122"/>
                 <a:cs typeface="Calibri" pitchFamily="34" charset="-120"/>
               </a:rPr>
-              <a:t>Latest:  Raipur +2,399  |  NCR +1,791     •     Avg:  Raipur -111  |  NCR -285 INR/MT</a:t>
+              <a:t>Latest:  Raipur +395  |  NCR -55     •     Avg:  Raipur -85  |  NCR -287 INR/MT</a:t>
             </a:r>
             <a:endParaRPr lang="en-US" sz="1100" dirty="0"/>
           </a:p>
@@ -5498,7 +5564,7 @@
                 <a:ea typeface="Calibri" pitchFamily="34" charset="-122"/>
                 <a:cs typeface="Calibri" pitchFamily="34" charset="-120"/>
               </a:rPr>
-              <a:t>Latest:  Raipur +2,246  |  NCR +2,887     •     Avg:  Raipur 346  |  NCR 1,123 INR/MT</a:t>
+              <a:t>Latest:  Raipur +494  |  NCR +843     •     Avg:  Raipur 370  |  NCR 1,157 INR/MT</a:t>
             </a:r>
             <a:endParaRPr lang="en-US" sz="1100" dirty="0"/>
           </a:p>

</xml_diff>

<commit_message>
Handle FoR-Delhi/NCR rebar label and regenerate graphs to 2026-10-15
Co-Authored-By: Claude Opus 5.5 <noreply@anthropic.com>
Claude-Session: https://claude.ai/code/session_01MztwMJnz2CCbYvjHcZqkdz
</commit_message>
<xml_diff>
--- a/output/material_change_graphs.pptx
+++ b/output/material_change_graphs.pptx
@@ -170,9 +170,9 @@
           </c:dLbls>
           <c:cat>
             <c:multiLvlStrRef>
-              <c:f>Sheet1!$A$2:$A$23</c:f>
+              <c:f>Sheet1!$A$2:$A$24</c:f>
               <c:multiLvlStrCache>
-                <c:ptCount val="22"/>
+                <c:ptCount val="23"/>
                 <c:lvl>
                   <c:pt idx="0">
                     <c:v>Dec'24</c:v>
@@ -259,7 +259,11 @@
                   </c:pt>
                   <c:pt idx="21">
                     <c:v>Sep'26
-R:+900 | N:-1,100</c:v>
+R:+1,900 | N:+300</c:v>
+                  </c:pt>
+                  <c:pt idx="22">
+                    <c:v>Oct'26
+R:-900 | N:-1,800</c:v>
                   </c:pt>
                 </c:lvl>
               </c:multiLvlStrCache>
@@ -267,10 +271,10 @@
           </c:cat>
           <c:val>
             <c:numRef>
-              <c:f>Sheet1!$B$2:$B$23</c:f>
+              <c:f>Sheet1!$B$2:$B$24</c:f>
               <c:numCache>
                 <c:formatCode>General</c:formatCode>
-                <c:ptCount val="22"/>
+                <c:ptCount val="23"/>
                 <c:pt idx="0">
                   <c:v>31300</c:v>
                 </c:pt>
@@ -335,7 +339,10 @@
                   <c:v>36500</c:v>
                 </c:pt>
                 <c:pt idx="21">
-                  <c:v>37400</c:v>
+                  <c:v>38400</c:v>
+                </c:pt>
+                <c:pt idx="22">
+                  <c:v>37500</c:v>
                 </c:pt>
               </c:numCache>
             </c:numRef>
@@ -388,9 +395,9 @@
           </c:dLbls>
           <c:cat>
             <c:multiLvlStrRef>
-              <c:f>Sheet1!$A$2:$A$23</c:f>
+              <c:f>Sheet1!$A$2:$A$24</c:f>
               <c:multiLvlStrCache>
-                <c:ptCount val="22"/>
+                <c:ptCount val="23"/>
                 <c:lvl>
                   <c:pt idx="0">
                     <c:v>Dec'24</c:v>
@@ -477,7 +484,11 @@
                   </c:pt>
                   <c:pt idx="21">
                     <c:v>Sep'26
-R:+900 | N:-1,100</c:v>
+R:+1,900 | N:+300</c:v>
+                  </c:pt>
+                  <c:pt idx="22">
+                    <c:v>Oct'26
+R:-900 | N:-1,800</c:v>
                   </c:pt>
                 </c:lvl>
               </c:multiLvlStrCache>
@@ -485,10 +496,10 @@
           </c:cat>
           <c:val>
             <c:numRef>
-              <c:f>Sheet1!$C$2:$C$23</c:f>
+              <c:f>Sheet1!$C$2:$C$24</c:f>
               <c:numCache>
                 <c:formatCode>General</c:formatCode>
-                <c:ptCount val="22"/>
+                <c:ptCount val="23"/>
                 <c:pt idx="0">
                   <c:v>33100</c:v>
                 </c:pt>
@@ -553,7 +564,10 @@
                   <c:v>38900</c:v>
                 </c:pt>
                 <c:pt idx="21">
-                  <c:v>37800</c:v>
+                  <c:v>39200</c:v>
+                </c:pt>
+                <c:pt idx="22">
+                  <c:v>37400</c:v>
                 </c:pt>
               </c:numCache>
             </c:numRef>
@@ -807,9 +821,9 @@
           </c:marker>
           <c:cat>
             <c:multiLvlStrRef>
-              <c:f>Sheet1!$A$2:$A$23</c:f>
+              <c:f>Sheet1!$A$2:$A$24</c:f>
               <c:multiLvlStrCache>
-                <c:ptCount val="22"/>
+                <c:ptCount val="23"/>
                 <c:lvl>
                   <c:pt idx="0">
                     <c:v>Dec'24</c:v>
@@ -876,6 +890,9 @@
                   </c:pt>
                   <c:pt idx="21">
                     <c:v>Sep'26</c:v>
+                  </c:pt>
+                  <c:pt idx="22">
+                    <c:v>Oct'26</c:v>
                   </c:pt>
                 </c:lvl>
               </c:multiLvlStrCache>
@@ -883,10 +900,10 @@
           </c:cat>
           <c:val>
             <c:numRef>
-              <c:f>Sheet1!$B$2:$B$23</c:f>
+              <c:f>Sheet1!$B$2:$B$24</c:f>
               <c:numCache>
                 <c:formatCode>General</c:formatCode>
-                <c:ptCount val="22"/>
+                <c:ptCount val="23"/>
                 <c:pt idx="0">
                   <c:v>24200</c:v>
                 </c:pt>
@@ -951,7 +968,10 @@
                   <c:v>29700</c:v>
                 </c:pt>
                 <c:pt idx="21">
-                  <c:v>28100</c:v>
+                  <c:v>29300</c:v>
+                </c:pt>
+                <c:pt idx="22">
+                  <c:v>28150</c:v>
                 </c:pt>
               </c:numCache>
             </c:numRef>
@@ -1029,9 +1049,9 @@
           </c:marker>
           <c:cat>
             <c:multiLvlStrRef>
-              <c:f>Sheet1!$A$2:$A$23</c:f>
+              <c:f>Sheet1!$A$2:$A$24</c:f>
               <c:multiLvlStrCache>
-                <c:ptCount val="22"/>
+                <c:ptCount val="23"/>
                 <c:lvl>
                   <c:pt idx="0">
                     <c:v>Dec'24</c:v>
@@ -1098,6 +1118,9 @@
                   </c:pt>
                   <c:pt idx="21">
                     <c:v>Sep'26</c:v>
+                  </c:pt>
+                  <c:pt idx="22">
+                    <c:v>Oct'26</c:v>
                   </c:pt>
                 </c:lvl>
               </c:multiLvlStrCache>
@@ -1105,10 +1128,10 @@
           </c:cat>
           <c:val>
             <c:numRef>
-              <c:f>Sheet1!$C$2:$C$23</c:f>
+              <c:f>Sheet1!$C$2:$C$24</c:f>
               <c:numCache>
                 <c:formatCode>General</c:formatCode>
-                <c:ptCount val="22"/>
+                <c:ptCount val="23"/>
                 <c:pt idx="0">
                   <c:v>32550</c:v>
                 </c:pt>
@@ -1173,7 +1196,10 @@
                   <c:v>40000</c:v>
                 </c:pt>
                 <c:pt idx="21">
-                  <c:v>41950</c:v>
+                  <c:v>42700</c:v>
+                </c:pt>
+                <c:pt idx="22">
+                  <c:v>42950</c:v>
                 </c:pt>
               </c:numCache>
             </c:numRef>
@@ -1251,9 +1277,9 @@
           </c:marker>
           <c:cat>
             <c:multiLvlStrRef>
-              <c:f>Sheet1!$A$2:$A$23</c:f>
+              <c:f>Sheet1!$A$2:$A$24</c:f>
               <c:multiLvlStrCache>
-                <c:ptCount val="22"/>
+                <c:ptCount val="23"/>
                 <c:lvl>
                   <c:pt idx="0">
                     <c:v>Dec'24</c:v>
@@ -1320,6 +1346,9 @@
                   </c:pt>
                   <c:pt idx="21">
                     <c:v>Sep'26</c:v>
+                  </c:pt>
+                  <c:pt idx="22">
+                    <c:v>Oct'26</c:v>
                   </c:pt>
                 </c:lvl>
               </c:multiLvlStrCache>
@@ -1327,10 +1356,10 @@
           </c:cat>
           <c:val>
             <c:numRef>
-              <c:f>Sheet1!$D$2:$D$23</c:f>
+              <c:f>Sheet1!$D$2:$D$24</c:f>
               <c:numCache>
                 <c:formatCode>General</c:formatCode>
-                <c:ptCount val="22"/>
+                <c:ptCount val="23"/>
                 <c:pt idx="0">
                   <c:v>28800</c:v>
                 </c:pt>
@@ -1395,7 +1424,10 @@
                   <c:v>33700</c:v>
                 </c:pt>
                 <c:pt idx="21">
-                  <c:v>32350</c:v>
+                  <c:v>34100</c:v>
+                </c:pt>
+                <c:pt idx="22">
+                  <c:v>32650</c:v>
                 </c:pt>
               </c:numCache>
             </c:numRef>
@@ -1473,9 +1505,9 @@
           </c:marker>
           <c:cat>
             <c:multiLvlStrRef>
-              <c:f>Sheet1!$A$2:$A$23</c:f>
+              <c:f>Sheet1!$A$2:$A$24</c:f>
               <c:multiLvlStrCache>
-                <c:ptCount val="22"/>
+                <c:ptCount val="23"/>
                 <c:lvl>
                   <c:pt idx="0">
                     <c:v>Dec'24</c:v>
@@ -1542,6 +1574,9 @@
                   </c:pt>
                   <c:pt idx="21">
                     <c:v>Sep'26</c:v>
+                  </c:pt>
+                  <c:pt idx="22">
+                    <c:v>Oct'26</c:v>
                   </c:pt>
                 </c:lvl>
               </c:multiLvlStrCache>
@@ -1549,10 +1584,10 @@
           </c:cat>
           <c:val>
             <c:numRef>
-              <c:f>Sheet1!$E$2:$E$23</c:f>
+              <c:f>Sheet1!$E$2:$E$24</c:f>
               <c:numCache>
                 <c:formatCode>General</c:formatCode>
-                <c:ptCount val="22"/>
+                <c:ptCount val="23"/>
                 <c:pt idx="0">
                   <c:v>26200</c:v>
                 </c:pt>
@@ -1617,7 +1652,10 @@
                   <c:v>29839.999999999996</c:v>
                 </c:pt>
                 <c:pt idx="21">
-                  <c:v>31439.999999999996</c:v>
+                  <c:v>32720</c:v>
+                </c:pt>
+                <c:pt idx="22">
+                  <c:v>33600</c:v>
                 </c:pt>
               </c:numCache>
             </c:numRef>
@@ -1849,9 +1887,9 @@
           </c:dLbls>
           <c:cat>
             <c:multiLvlStrRef>
-              <c:f>Sheet1!$A$2:$A$23</c:f>
+              <c:f>Sheet1!$A$2:$A$24</c:f>
               <c:multiLvlStrCache>
-                <c:ptCount val="22"/>
+                <c:ptCount val="23"/>
                 <c:lvl>
                   <c:pt idx="0">
                     <c:v>Dec'24</c:v>
@@ -1938,7 +1976,11 @@
                   </c:pt>
                   <c:pt idx="21">
                     <c:v>Sep'26
-R:+2,622 | N:+2,088</c:v>
+R:+2,399 | N:+1,791</c:v>
+                  </c:pt>
+                  <c:pt idx="22">
+                    <c:v>Oct'26
+R:+431 | N:-72</c:v>
                   </c:pt>
                 </c:lvl>
               </c:multiLvlStrCache>
@@ -1946,10 +1988,10 @@
           </c:cat>
           <c:val>
             <c:numRef>
-              <c:f>Sheet1!$B$2:$B$23</c:f>
+              <c:f>Sheet1!$B$2:$B$24</c:f>
               <c:numCache>
                 <c:formatCode>General</c:formatCode>
-                <c:ptCount val="22"/>
+                <c:ptCount val="23"/>
                 <c:pt idx="0">
                   <c:v>518.69</c:v>
                 </c:pt>
@@ -2014,7 +2056,10 @@
                   <c:v>-2309.77</c:v>
                 </c:pt>
                 <c:pt idx="21">
-                  <c:v>312.26</c:v>
+                  <c:v>89.21</c:v>
+                </c:pt>
+                <c:pt idx="22">
+                  <c:v>520.37</c:v>
                 </c:pt>
               </c:numCache>
             </c:numRef>
@@ -2067,9 +2112,9 @@
           </c:dLbls>
           <c:cat>
             <c:multiLvlStrRef>
-              <c:f>Sheet1!$A$2:$A$23</c:f>
+              <c:f>Sheet1!$A$2:$A$24</c:f>
               <c:multiLvlStrCache>
-                <c:ptCount val="22"/>
+                <c:ptCount val="23"/>
                 <c:lvl>
                   <c:pt idx="0">
                     <c:v>Dec'24</c:v>
@@ -2156,7 +2201,11 @@
                   </c:pt>
                   <c:pt idx="21">
                     <c:v>Sep'26
-R:+2,622 | N:+2,088</c:v>
+R:+2,399 | N:+1,791</c:v>
+                  </c:pt>
+                  <c:pt idx="22">
+                    <c:v>Oct'26
+R:+431 | N:-72</c:v>
                   </c:pt>
                 </c:lvl>
               </c:multiLvlStrCache>
@@ -2164,10 +2213,10 @@
           </c:cat>
           <c:val>
             <c:numRef>
-              <c:f>Sheet1!$C$2:$C$23</c:f>
+              <c:f>Sheet1!$C$2:$C$24</c:f>
               <c:numCache>
                 <c:formatCode>General</c:formatCode>
-                <c:ptCount val="22"/>
+                <c:ptCount val="23"/>
                 <c:pt idx="0">
                   <c:v>85.71</c:v>
                 </c:pt>
@@ -2232,7 +2281,10 @@
                   <c:v>-2059.16</c:v>
                 </c:pt>
                 <c:pt idx="21">
-                  <c:v>28.44</c:v>
+                  <c:v>-268.49</c:v>
+                </c:pt>
+                <c:pt idx="22">
+                  <c:v>-340.54</c:v>
                 </c:pt>
               </c:numCache>
             </c:numRef>
@@ -2464,9 +2516,9 @@
           </c:dLbls>
           <c:cat>
             <c:multiLvlStrRef>
-              <c:f>Sheet1!$A$2:$A$23</c:f>
+              <c:f>Sheet1!$A$2:$A$24</c:f>
               <c:multiLvlStrCache>
-                <c:ptCount val="22"/>
+                <c:ptCount val="23"/>
                 <c:lvl>
                   <c:pt idx="0">
                     <c:v>Dec'24</c:v>
@@ -2553,7 +2605,11 @@
                   </c:pt>
                   <c:pt idx="21">
                     <c:v>Sep'26
-R:+2,531 | N:+2,046</c:v>
+R:+2,246 | N:+2,887</c:v>
+                  </c:pt>
+                  <c:pt idx="22">
+                    <c:v>Oct'26
+R:+1,191 | N:+739</c:v>
                   </c:pt>
                 </c:lvl>
               </c:multiLvlStrCache>
@@ -2561,10 +2617,10 @@
           </c:cat>
           <c:val>
             <c:numRef>
-              <c:f>Sheet1!$B$2:$B$23</c:f>
+              <c:f>Sheet1!$B$2:$B$24</c:f>
               <c:numCache>
                 <c:formatCode>General</c:formatCode>
-                <c:ptCount val="22"/>
+                <c:ptCount val="23"/>
                 <c:pt idx="0">
                   <c:v>785.24</c:v>
                 </c:pt>
@@ -2629,7 +2685,10 @@
                   <c:v>-1848.25</c:v>
                 </c:pt>
                 <c:pt idx="21">
-                  <c:v>682.76</c:v>
+                  <c:v>397.93</c:v>
+                </c:pt>
+                <c:pt idx="22">
+                  <c:v>1588.53</c:v>
                 </c:pt>
               </c:numCache>
             </c:numRef>
@@ -2682,9 +2741,9 @@
           </c:dLbls>
           <c:cat>
             <c:multiLvlStrRef>
-              <c:f>Sheet1!$A$2:$A$23</c:f>
+              <c:f>Sheet1!$A$2:$A$24</c:f>
               <c:multiLvlStrCache>
-                <c:ptCount val="22"/>
+                <c:ptCount val="23"/>
                 <c:lvl>
                   <c:pt idx="0">
                     <c:v>Dec'24</c:v>
@@ -2771,7 +2830,11 @@
                   </c:pt>
                   <c:pt idx="21">
                     <c:v>Sep'26
-R:+2,531 | N:+2,046</c:v>
+R:+2,246 | N:+2,887</c:v>
+                  </c:pt>
+                  <c:pt idx="22">
+                    <c:v>Oct'26
+R:+1,191 | N:+739</c:v>
                   </c:pt>
                 </c:lvl>
               </c:multiLvlStrCache>
@@ -2779,10 +2842,10 @@
           </c:cat>
           <c:val>
             <c:numRef>
-              <c:f>Sheet1!$C$2:$C$23</c:f>
+              <c:f>Sheet1!$C$2:$C$24</c:f>
               <c:numCache>
                 <c:formatCode>General</c:formatCode>
-                <c:ptCount val="22"/>
+                <c:ptCount val="23"/>
                 <c:pt idx="0">
                   <c:v>1176.79</c:v>
                 </c:pt>
@@ -2847,7 +2910,10 @@
                   <c:v>-1822.03</c:v>
                 </c:pt>
                 <c:pt idx="21">
-                  <c:v>223.87</c:v>
+                  <c:v>1065.37</c:v>
+                </c:pt>
+                <c:pt idx="22">
+                  <c:v>1804.74</c:v>
                 </c:pt>
               </c:numCache>
             </c:numRef>
@@ -4325,7 +4391,7 @@
                 <a:ea typeface="Calibri" pitchFamily="34" charset="-122"/>
                 <a:cs typeface="Calibri" pitchFamily="34" charset="-120"/>
               </a:rPr>
-              <a:t>Period: 2024-12-12 to 2026-09-23  |  22 months</a:t>
+              <a:t>Period: 2024-12-12 to 2026-10-15  |  23 months</a:t>
             </a:r>
             <a:endParaRPr lang="en-US" sz="1200" dirty="0"/>
           </a:p>
@@ -4589,7 +4655,7 @@
                 <a:ea typeface="Calibri" pitchFamily="34" charset="-122"/>
                 <a:cs typeface="Calibri" pitchFamily="34" charset="-120"/>
               </a:rPr>
-              <a:t>Latest:  Raipur +900  |  NCR -1,100     •     Avg:  Raipur 33,052  |  NCR 33,527 INR/MT</a:t>
+              <a:t>Latest:  Raipur -900  |  NCR -1,800     •     Avg:  Raipur 33,289  |  NCR 33,757 INR/MT</a:t>
             </a:r>
             <a:endParaRPr lang="en-US" sz="1100" dirty="0"/>
           </a:p>
@@ -4892,7 +4958,7 @@
                 <a:ea typeface="Calibri" pitchFamily="34" charset="-122"/>
                 <a:cs typeface="Calibri" pitchFamily="34" charset="-120"/>
               </a:rPr>
-              <a:t>Latest change:  Pallet DRI: -1,600 INR/MT  |  Pig Iron: +1,950 INR/MT  |  Iron Ore DRI: -1,350 INR/MT  |  Silico Manganese: +4.0 INR/kg</a:t>
+              <a:t>Latest change:  Pallet DRI: -1,150 INR/MT  |  Pig Iron: +250 INR/MT  |  Iron Ore DRI: -1,450 INR/MT  |  Silico Manganese: +2.2 INR/kg</a:t>
             </a:r>
             <a:endParaRPr lang="en-US" sz="1100" dirty="0"/>
           </a:p>
@@ -5195,7 +5261,7 @@
                 <a:ea typeface="Calibri" pitchFamily="34" charset="-122"/>
                 <a:cs typeface="Calibri" pitchFamily="34" charset="-120"/>
               </a:rPr>
-              <a:t>Latest:  Raipur +2,622  |  NCR +2,088     •     Avg:  Raipur -100  |  NCR -272 INR/MT</a:t>
+              <a:t>Latest:  Raipur +431  |  NCR -72     •     Avg:  Raipur -83  |  NCR -288 INR/MT</a:t>
             </a:r>
             <a:endParaRPr lang="en-US" sz="1100" dirty="0"/>
           </a:p>
@@ -5498,7 +5564,7 @@
                 <a:ea typeface="Calibri" pitchFamily="34" charset="-122"/>
                 <a:cs typeface="Calibri" pitchFamily="34" charset="-120"/>
               </a:rPr>
-              <a:t>Latest:  Raipur +2,531  |  NCR +2,046     •     Avg:  Raipur 359  |  NCR 1,084 INR/MT</a:t>
+              <a:t>Latest:  Raipur +1,191  |  NCR +739     •     Avg:  Raipur 400  |  NCR 1,152 INR/MT</a:t>
             </a:r>
             <a:endParaRPr lang="en-US" sz="1100" dirty="0"/>
           </a:p>

</xml_diff>

<commit_message>
Regenerate material change graphs for 2026-10-19 update
Co-Authored-By: Claude Opus 5.5 <noreply@anthropic.com>
Claude-Session: https://claude.ai/code/session_01MztwMJnz2CCbYvjHcZqkdz
</commit_message>
<xml_diff>
--- a/output/material_change_graphs.pptx
+++ b/output/material_change_graphs.pptx
@@ -263,7 +263,7 @@
                   </c:pt>
                   <c:pt idx="22">
                     <c:v>Oct'26
-R:-900 | N:-1,800</c:v>
+R:-1,900 | N:-2,600</c:v>
                   </c:pt>
                 </c:lvl>
               </c:multiLvlStrCache>
@@ -342,7 +342,7 @@
                   <c:v>38400</c:v>
                 </c:pt>
                 <c:pt idx="22">
-                  <c:v>37500</c:v>
+                  <c:v>36500</c:v>
                 </c:pt>
               </c:numCache>
             </c:numRef>
@@ -488,7 +488,7 @@
                   </c:pt>
                   <c:pt idx="22">
                     <c:v>Oct'26
-R:-900 | N:-1,800</c:v>
+R:-1,900 | N:-2,600</c:v>
                   </c:pt>
                 </c:lvl>
               </c:multiLvlStrCache>
@@ -567,7 +567,7 @@
                   <c:v>39200</c:v>
                 </c:pt>
                 <c:pt idx="22">
-                  <c:v>37400</c:v>
+                  <c:v>36600</c:v>
                 </c:pt>
               </c:numCache>
             </c:numRef>
@@ -971,7 +971,7 @@
                   <c:v>29300</c:v>
                 </c:pt>
                 <c:pt idx="22">
-                  <c:v>28150</c:v>
+                  <c:v>27500</c:v>
                 </c:pt>
               </c:numCache>
             </c:numRef>
@@ -1199,7 +1199,7 @@
                   <c:v>42700</c:v>
                 </c:pt>
                 <c:pt idx="22">
-                  <c:v>42950</c:v>
+                  <c:v>42500</c:v>
                 </c:pt>
               </c:numCache>
             </c:numRef>
@@ -1427,7 +1427,7 @@
                   <c:v>34100</c:v>
                 </c:pt>
                 <c:pt idx="22">
-                  <c:v>32650</c:v>
+                  <c:v>31900</c:v>
                 </c:pt>
               </c:numCache>
             </c:numRef>
@@ -1655,7 +1655,7 @@
                   <c:v>32720</c:v>
                 </c:pt>
                 <c:pt idx="22">
-                  <c:v>33600</c:v>
+                  <c:v>33360</c:v>
                 </c:pt>
               </c:numCache>
             </c:numRef>
@@ -1980,7 +1980,7 @@
                   </c:pt>
                   <c:pt idx="22">
                     <c:v>Oct'26
-R:+431 | N:-72</c:v>
+R:+443 | N:+123</c:v>
                   </c:pt>
                 </c:lvl>
               </c:multiLvlStrCache>
@@ -2059,7 +2059,7 @@
                   <c:v>89.21</c:v>
                 </c:pt>
                 <c:pt idx="22">
-                  <c:v>520.37</c:v>
+                  <c:v>532.17</c:v>
                 </c:pt>
               </c:numCache>
             </c:numRef>
@@ -2205,7 +2205,7 @@
                   </c:pt>
                   <c:pt idx="22">
                     <c:v>Oct'26
-R:+431 | N:-72</c:v>
+R:+443 | N:+123</c:v>
                   </c:pt>
                 </c:lvl>
               </c:multiLvlStrCache>
@@ -2284,7 +2284,7 @@
                   <c:v>-268.49</c:v>
                 </c:pt>
                 <c:pt idx="22">
-                  <c:v>-340.54</c:v>
+                  <c:v>-145.36</c:v>
                 </c:pt>
               </c:numCache>
             </c:numRef>
@@ -2609,7 +2609,7 @@
                   </c:pt>
                   <c:pt idx="22">
                     <c:v>Oct'26
-R:+1,191 | N:+739</c:v>
+R:+1,609 | N:+941</c:v>
                   </c:pt>
                 </c:lvl>
               </c:multiLvlStrCache>
@@ -2688,7 +2688,7 @@
                   <c:v>397.93</c:v>
                 </c:pt>
                 <c:pt idx="22">
-                  <c:v>1588.53</c:v>
+                  <c:v>2006.82</c:v>
                 </c:pt>
               </c:numCache>
             </c:numRef>
@@ -2834,7 +2834,7 @@
                   </c:pt>
                   <c:pt idx="22">
                     <c:v>Oct'26
-R:+1,191 | N:+739</c:v>
+R:+1,609 | N:+941</c:v>
                   </c:pt>
                 </c:lvl>
               </c:multiLvlStrCache>
@@ -2913,7 +2913,7 @@
                   <c:v>1065.37</c:v>
                 </c:pt>
                 <c:pt idx="22">
-                  <c:v>1804.74</c:v>
+                  <c:v>2006.27</c:v>
                 </c:pt>
               </c:numCache>
             </c:numRef>
@@ -4391,7 +4391,7 @@
                 <a:ea typeface="Calibri" pitchFamily="34" charset="-122"/>
                 <a:cs typeface="Calibri" pitchFamily="34" charset="-120"/>
               </a:rPr>
-              <a:t>Period: 2024-12-12 to 2026-10-15  |  23 months</a:t>
+              <a:t>Period: 2024-12-12 to 2026-10-19  |  23 months</a:t>
             </a:r>
             <a:endParaRPr lang="en-US" sz="1200" dirty="0"/>
           </a:p>
@@ -4655,7 +4655,7 @@
                 <a:ea typeface="Calibri" pitchFamily="34" charset="-122"/>
                 <a:cs typeface="Calibri" pitchFamily="34" charset="-120"/>
               </a:rPr>
-              <a:t>Latest:  Raipur -900  |  NCR -1,800     •     Avg:  Raipur 33,289  |  NCR 33,757 INR/MT</a:t>
+              <a:t>Latest:  Raipur -1,900  |  NCR -2,600     •     Avg:  Raipur 33,246  |  NCR 33,722 INR/MT</a:t>
             </a:r>
             <a:endParaRPr lang="en-US" sz="1100" dirty="0"/>
           </a:p>
@@ -4958,7 +4958,7 @@
                 <a:ea typeface="Calibri" pitchFamily="34" charset="-122"/>
                 <a:cs typeface="Calibri" pitchFamily="34" charset="-120"/>
               </a:rPr>
-              <a:t>Latest change:  Pallet DRI: -1,150 INR/MT  |  Pig Iron: +250 INR/MT  |  Iron Ore DRI: -1,450 INR/MT  |  Silico Manganese: +2.2 INR/kg</a:t>
+              <a:t>Latest change:  Pallet DRI: -1,800 INR/MT  |  Pig Iron: -200 INR/MT  |  Iron Ore DRI: -2,200 INR/MT  |  Silico Manganese: +1.6 INR/kg</a:t>
             </a:r>
             <a:endParaRPr lang="en-US" sz="1100" dirty="0"/>
           </a:p>
@@ -5261,7 +5261,7 @@
                 <a:ea typeface="Calibri" pitchFamily="34" charset="-122"/>
                 <a:cs typeface="Calibri" pitchFamily="34" charset="-120"/>
               </a:rPr>
-              <a:t>Latest:  Raipur +431  |  NCR -72     •     Avg:  Raipur -83  |  NCR -288 INR/MT</a:t>
+              <a:t>Latest:  Raipur +443  |  NCR +123     •     Avg:  Raipur -83  |  NCR -279 INR/MT</a:t>
             </a:r>
             <a:endParaRPr lang="en-US" sz="1100" dirty="0"/>
           </a:p>
@@ -5564,7 +5564,7 @@
                 <a:ea typeface="Calibri" pitchFamily="34" charset="-122"/>
                 <a:cs typeface="Calibri" pitchFamily="34" charset="-120"/>
               </a:rPr>
-              <a:t>Latest:  Raipur +1,191  |  NCR +739     •     Avg:  Raipur 400  |  NCR 1,152 INR/MT</a:t>
+              <a:t>Latest:  Raipur +1,609  |  NCR +941     •     Avg:  Raipur 418  |  NCR 1,161 INR/MT</a:t>
             </a:r>
             <a:endParaRPr lang="en-US" sz="1100" dirty="0"/>
           </a:p>

</xml_diff>

<commit_message>
Regenerate material change graphs for 2026-10-21 update
Co-Authored-By: Claude Opus 5.5 <noreply@anthropic.com>
Claude-Session: https://claude.ai/code/session_01MztwMJnz2CCbYvjHcZqkdz
</commit_message>
<xml_diff>
--- a/output/material_change_graphs.pptx
+++ b/output/material_change_graphs.pptx
@@ -263,7 +263,7 @@
                   </c:pt>
                   <c:pt idx="22">
                     <c:v>Oct'26
-R:-1,900 | N:-2,600</c:v>
+R:-1,900 | N:-2,150</c:v>
                   </c:pt>
                 </c:lvl>
               </c:multiLvlStrCache>
@@ -488,7 +488,7 @@
                   </c:pt>
                   <c:pt idx="22">
                     <c:v>Oct'26
-R:-1,900 | N:-2,600</c:v>
+R:-1,900 | N:-2,150</c:v>
                   </c:pt>
                 </c:lvl>
               </c:multiLvlStrCache>
@@ -567,7 +567,7 @@
                   <c:v>39200</c:v>
                 </c:pt>
                 <c:pt idx="22">
-                  <c:v>36600</c:v>
+                  <c:v>37050</c:v>
                 </c:pt>
               </c:numCache>
             </c:numRef>
@@ -971,7 +971,7 @@
                   <c:v>29300</c:v>
                 </c:pt>
                 <c:pt idx="22">
-                  <c:v>27500</c:v>
+                  <c:v>27800</c:v>
                 </c:pt>
               </c:numCache>
             </c:numRef>
@@ -1427,7 +1427,7 @@
                   <c:v>34100</c:v>
                 </c:pt>
                 <c:pt idx="22">
-                  <c:v>31900</c:v>
+                  <c:v>32100</c:v>
                 </c:pt>
               </c:numCache>
             </c:numRef>
@@ -1655,7 +1655,7 @@
                   <c:v>32720</c:v>
                 </c:pt>
                 <c:pt idx="22">
-                  <c:v>33360</c:v>
+                  <c:v>33120</c:v>
                 </c:pt>
               </c:numCache>
             </c:numRef>
@@ -1980,7 +1980,7 @@
                   </c:pt>
                   <c:pt idx="22">
                     <c:v>Oct'26
-R:+443 | N:+123</c:v>
+R:+773 | N:+353</c:v>
                   </c:pt>
                 </c:lvl>
               </c:multiLvlStrCache>
@@ -2059,7 +2059,7 @@
                   <c:v>89.21</c:v>
                 </c:pt>
                 <c:pt idx="22">
-                  <c:v>532.17</c:v>
+                  <c:v>861.76</c:v>
                 </c:pt>
               </c:numCache>
             </c:numRef>
@@ -2205,7 +2205,7 @@
                   </c:pt>
                   <c:pt idx="22">
                     <c:v>Oct'26
-R:+443 | N:+123</c:v>
+R:+773 | N:+353</c:v>
                   </c:pt>
                 </c:lvl>
               </c:multiLvlStrCache>
@@ -2284,7 +2284,7 @@
                   <c:v>-268.49</c:v>
                 </c:pt>
                 <c:pt idx="22">
-                  <c:v>-145.36</c:v>
+                  <c:v>84.36</c:v>
                 </c:pt>
               </c:numCache>
             </c:numRef>
@@ -2609,7 +2609,7 @@
                   </c:pt>
                   <c:pt idx="22">
                     <c:v>Oct'26
-R:+1,609 | N:+941</c:v>
+R:+1,636 | N:+768</c:v>
                   </c:pt>
                 </c:lvl>
               </c:multiLvlStrCache>
@@ -2688,7 +2688,7 @@
                   <c:v>397.93</c:v>
                 </c:pt>
                 <c:pt idx="22">
-                  <c:v>2006.82</c:v>
+                  <c:v>2034.25</c:v>
                 </c:pt>
               </c:numCache>
             </c:numRef>
@@ -2834,7 +2834,7 @@
                   </c:pt>
                   <c:pt idx="22">
                     <c:v>Oct'26
-R:+1,609 | N:+941</c:v>
+R:+1,636 | N:+768</c:v>
                   </c:pt>
                 </c:lvl>
               </c:multiLvlStrCache>
@@ -2913,7 +2913,7 @@
                   <c:v>1065.37</c:v>
                 </c:pt>
                 <c:pt idx="22">
-                  <c:v>2006.27</c:v>
+                  <c:v>1833.03</c:v>
                 </c:pt>
               </c:numCache>
             </c:numRef>
@@ -4391,7 +4391,7 @@
                 <a:ea typeface="Calibri" pitchFamily="34" charset="-122"/>
                 <a:cs typeface="Calibri" pitchFamily="34" charset="-120"/>
               </a:rPr>
-              <a:t>Period: 2024-12-12 to 2026-10-19  |  23 months</a:t>
+              <a:t>Period: 2024-12-12 to 2026-10-21  |  23 months</a:t>
             </a:r>
             <a:endParaRPr lang="en-US" sz="1200" dirty="0"/>
           </a:p>
@@ -4655,7 +4655,7 @@
                 <a:ea typeface="Calibri" pitchFamily="34" charset="-122"/>
                 <a:cs typeface="Calibri" pitchFamily="34" charset="-120"/>
               </a:rPr>
-              <a:t>Latest:  Raipur -1,900  |  NCR -2,600     •     Avg:  Raipur 33,246  |  NCR 33,722 INR/MT</a:t>
+              <a:t>Latest:  Raipur -1,900  |  NCR -2,150     •     Avg:  Raipur 33,246  |  NCR 33,741 INR/MT</a:t>
             </a:r>
             <a:endParaRPr lang="en-US" sz="1100" dirty="0"/>
           </a:p>
@@ -4958,7 +4958,7 @@
                 <a:ea typeface="Calibri" pitchFamily="34" charset="-122"/>
                 <a:cs typeface="Calibri" pitchFamily="34" charset="-120"/>
               </a:rPr>
-              <a:t>Latest change:  Pallet DRI: -1,800 INR/MT  |  Pig Iron: -200 INR/MT  |  Iron Ore DRI: -2,200 INR/MT  |  Silico Manganese: +1.6 INR/kg</a:t>
+              <a:t>Latest change:  Pallet DRI: -1,500 INR/MT  |  Pig Iron: -200 INR/MT  |  Iron Ore DRI: -2,000 INR/MT  |  Silico Manganese: +1.0 INR/kg</a:t>
             </a:r>
             <a:endParaRPr lang="en-US" sz="1100" dirty="0"/>
           </a:p>
@@ -5261,7 +5261,7 @@
                 <a:ea typeface="Calibri" pitchFamily="34" charset="-122"/>
                 <a:cs typeface="Calibri" pitchFamily="34" charset="-120"/>
               </a:rPr>
-              <a:t>Latest:  Raipur +443  |  NCR +123     •     Avg:  Raipur -83  |  NCR -279 INR/MT</a:t>
+              <a:t>Latest:  Raipur +773  |  NCR +353     •     Avg:  Raipur -68  |  NCR -269 INR/MT</a:t>
             </a:r>
             <a:endParaRPr lang="en-US" sz="1100" dirty="0"/>
           </a:p>
@@ -5564,7 +5564,7 @@
                 <a:ea typeface="Calibri" pitchFamily="34" charset="-122"/>
                 <a:cs typeface="Calibri" pitchFamily="34" charset="-120"/>
               </a:rPr>
-              <a:t>Latest:  Raipur +1,609  |  NCR +941     •     Avg:  Raipur 418  |  NCR 1,161 INR/MT</a:t>
+              <a:t>Latest:  Raipur +1,636  |  NCR +768     •     Avg:  Raipur 419  |  NCR 1,153 INR/MT</a:t>
             </a:r>
             <a:endParaRPr lang="en-US" sz="1100" dirty="0"/>
           </a:p>

</xml_diff>

<commit_message>
Add 28 Oct 2026 BigMint PDF, regenerate graphs, note PyMuPDF 1.x requirement
Co-Authored-By: Claude Opus 5.5 <noreply@anthropic.com>
Claude-Session: https://claude.ai/code/session_01MztwMJnz2CCbYvjHcZqkdz
</commit_message>
<xml_diff>
--- a/output/material_change_graphs.pptx
+++ b/output/material_change_graphs.pptx
@@ -263,7 +263,7 @@
                   </c:pt>
                   <c:pt idx="22">
                     <c:v>Oct'26
-R:-1,900 | N:-2,150</c:v>
+R:-2,500 | N:-2,900</c:v>
                   </c:pt>
                 </c:lvl>
               </c:multiLvlStrCache>
@@ -342,7 +342,7 @@
                   <c:v>38400</c:v>
                 </c:pt>
                 <c:pt idx="22">
-                  <c:v>36500</c:v>
+                  <c:v>35900</c:v>
                 </c:pt>
               </c:numCache>
             </c:numRef>
@@ -488,7 +488,7 @@
                   </c:pt>
                   <c:pt idx="22">
                     <c:v>Oct'26
-R:-1,900 | N:-2,150</c:v>
+R:-2,500 | N:-2,900</c:v>
                   </c:pt>
                 </c:lvl>
               </c:multiLvlStrCache>
@@ -567,7 +567,7 @@
                   <c:v>39200</c:v>
                 </c:pt>
                 <c:pt idx="22">
-                  <c:v>37050</c:v>
+                  <c:v>36300</c:v>
                 </c:pt>
               </c:numCache>
             </c:numRef>
@@ -971,7 +971,7 @@
                   <c:v>29300</c:v>
                 </c:pt>
                 <c:pt idx="22">
-                  <c:v>27800</c:v>
+                  <c:v>27600</c:v>
                 </c:pt>
               </c:numCache>
             </c:numRef>
@@ -1199,7 +1199,7 @@
                   <c:v>42700</c:v>
                 </c:pt>
                 <c:pt idx="22">
-                  <c:v>42500</c:v>
+                  <c:v>42200</c:v>
                 </c:pt>
               </c:numCache>
             </c:numRef>
@@ -1427,7 +1427,7 @@
                   <c:v>34100</c:v>
                 </c:pt>
                 <c:pt idx="22">
-                  <c:v>32100</c:v>
+                  <c:v>32400</c:v>
                 </c:pt>
               </c:numCache>
             </c:numRef>
@@ -1655,7 +1655,7 @@
                   <c:v>32720</c:v>
                 </c:pt>
                 <c:pt idx="22">
-                  <c:v>33120</c:v>
+                  <c:v>32800</c:v>
                 </c:pt>
               </c:numCache>
             </c:numRef>
@@ -1980,7 +1980,7 @@
                   </c:pt>
                   <c:pt idx="22">
                     <c:v>Oct'26
-R:+773 | N:+353</c:v>
+R:-281 | N:+189</c:v>
                   </c:pt>
                 </c:lvl>
               </c:multiLvlStrCache>
@@ -2059,7 +2059,7 @@
                   <c:v>89.21</c:v>
                 </c:pt>
                 <c:pt idx="22">
-                  <c:v>861.76</c:v>
+                  <c:v>-191.96</c:v>
                 </c:pt>
               </c:numCache>
             </c:numRef>
@@ -2205,7 +2205,7 @@
                   </c:pt>
                   <c:pt idx="22">
                     <c:v>Oct'26
-R:+773 | N:+353</c:v>
+R:-281 | N:+189</c:v>
                   </c:pt>
                 </c:lvl>
               </c:multiLvlStrCache>
@@ -2284,7 +2284,7 @@
                   <c:v>-268.49</c:v>
                 </c:pt>
                 <c:pt idx="22">
-                  <c:v>84.36</c:v>
+                  <c:v>-79.32</c:v>
                 </c:pt>
               </c:numCache>
             </c:numRef>
@@ -2609,7 +2609,7 @@
                   </c:pt>
                   <c:pt idx="22">
                     <c:v>Oct'26
-R:+1,636 | N:+768</c:v>
+R:+685 | N:+808</c:v>
                   </c:pt>
                 </c:lvl>
               </c:multiLvlStrCache>
@@ -2688,7 +2688,7 @@
                   <c:v>397.93</c:v>
                 </c:pt>
                 <c:pt idx="22">
-                  <c:v>2034.25</c:v>
+                  <c:v>1082.5</c:v>
                 </c:pt>
               </c:numCache>
             </c:numRef>
@@ -2834,7 +2834,7 @@
                   </c:pt>
                   <c:pt idx="22">
                     <c:v>Oct'26
-R:+1,636 | N:+768</c:v>
+R:+685 | N:+808</c:v>
                   </c:pt>
                 </c:lvl>
               </c:multiLvlStrCache>
@@ -2913,7 +2913,7 @@
                   <c:v>1065.37</c:v>
                 </c:pt>
                 <c:pt idx="22">
-                  <c:v>1833.03</c:v>
+                  <c:v>1873.65</c:v>
                 </c:pt>
               </c:numCache>
             </c:numRef>
@@ -4391,7 +4391,7 @@
                 <a:ea typeface="Calibri" pitchFamily="34" charset="-122"/>
                 <a:cs typeface="Calibri" pitchFamily="34" charset="-120"/>
               </a:rPr>
-              <a:t>Period: 2024-12-12 to 2026-10-21  |  23 months</a:t>
+              <a:t>Period: 2024-12-12 to 2026-10-28  |  23 months</a:t>
             </a:r>
             <a:endParaRPr lang="en-US" sz="1200" dirty="0"/>
           </a:p>
@@ -4655,7 +4655,7 @@
                 <a:ea typeface="Calibri" pitchFamily="34" charset="-122"/>
                 <a:cs typeface="Calibri" pitchFamily="34" charset="-120"/>
               </a:rPr>
-              <a:t>Latest:  Raipur -1,900  |  NCR -2,150     •     Avg:  Raipur 33,246  |  NCR 33,741 INR/MT</a:t>
+              <a:t>Latest:  Raipur -2,500  |  NCR -2,900     •     Avg:  Raipur 33,220  |  NCR 33,709 INR/MT</a:t>
             </a:r>
             <a:endParaRPr lang="en-US" sz="1100" dirty="0"/>
           </a:p>
@@ -4958,7 +4958,7 @@
                 <a:ea typeface="Calibri" pitchFamily="34" charset="-122"/>
                 <a:cs typeface="Calibri" pitchFamily="34" charset="-120"/>
               </a:rPr>
-              <a:t>Latest change:  Pallet DRI: -1,500 INR/MT  |  Pig Iron: -200 INR/MT  |  Iron Ore DRI: -2,000 INR/MT  |  Silico Manganese: +1.0 INR/kg</a:t>
+              <a:t>Latest change:  Pallet DRI: -1,700 INR/MT  |  Pig Iron: -500 INR/MT  |  Iron Ore DRI: -1,700 INR/MT  |  Silico Manganese: +0.2 INR/kg</a:t>
             </a:r>
             <a:endParaRPr lang="en-US" sz="1100" dirty="0"/>
           </a:p>
@@ -5261,7 +5261,7 @@
                 <a:ea typeface="Calibri" pitchFamily="34" charset="-122"/>
                 <a:cs typeface="Calibri" pitchFamily="34" charset="-120"/>
               </a:rPr>
-              <a:t>Latest:  Raipur +773  |  NCR +353     •     Avg:  Raipur -68  |  NCR -269 INR/MT</a:t>
+              <a:t>Latest:  Raipur -281  |  NCR +189     •     Avg:  Raipur -114  |  NCR -276 INR/MT</a:t>
             </a:r>
             <a:endParaRPr lang="en-US" sz="1100" dirty="0"/>
           </a:p>
@@ -5564,7 +5564,7 @@
                 <a:ea typeface="Calibri" pitchFamily="34" charset="-122"/>
                 <a:cs typeface="Calibri" pitchFamily="34" charset="-120"/>
               </a:rPr>
-              <a:t>Latest:  Raipur +1,636  |  NCR +768     •     Avg:  Raipur 419  |  NCR 1,153 INR/MT</a:t>
+              <a:t>Latest:  Raipur +685  |  NCR +808     •     Avg:  Raipur 378  |  NCR 1,155 INR/MT</a:t>
             </a:r>
             <a:endParaRPr lang="en-US" sz="1100" dirty="0"/>
           </a:p>

</xml_diff>